<commit_message>
Sync Sports Economics 059d813
</commit_message>
<xml_diff>
--- a/sports-econ/downloads/chapter-2-the-supply-and-demand-playbook.pptx
+++ b/sports-econ/downloads/chapter-2-the-supply-and-demand-playbook.pptx
@@ -2,31 +2,31 @@
 <file path=ppt/presentation.xml><?xml version="1.0" encoding="utf-8"?>
 <p:presentation xmlns:p="http://schemas.openxmlformats.org/presentationml/2006/main">
   <p:sldMasterIdLst>
-    <p:sldMasterId xmlns:r="http://schemas.openxmlformats.org/officeDocument/2006/relationships" id="2147483648" r:id="R8752ee95b98a4f7b"/>
+    <p:sldMasterId xmlns:r="http://schemas.openxmlformats.org/officeDocument/2006/relationships" id="2147483648" r:id="R576341ec2f6b4113"/>
   </p:sldMasterIdLst>
   <p:notesMasterIdLst>
-    <p:notesMasterId xmlns:r="http://schemas.openxmlformats.org/officeDocument/2006/relationships" r:id="R736e5bf1ffeb4d12"/>
+    <p:notesMasterId xmlns:r="http://schemas.openxmlformats.org/officeDocument/2006/relationships" r:id="Rdb73b54d23624c65"/>
   </p:notesMasterIdLst>
   <p:sldIdLst>
-    <p:sldId xmlns:r="http://schemas.openxmlformats.org/officeDocument/2006/relationships" id="256" r:id="Ra93fb614b01a4b2b"/>
-    <p:sldId xmlns:r="http://schemas.openxmlformats.org/officeDocument/2006/relationships" id="257" r:id="R27c24a2cce554c4e"/>
-    <p:sldId xmlns:r="http://schemas.openxmlformats.org/officeDocument/2006/relationships" id="258" r:id="R81ab207dad5d4b91"/>
-    <p:sldId xmlns:r="http://schemas.openxmlformats.org/officeDocument/2006/relationships" id="259" r:id="R8e012f3fccfe4bed"/>
-    <p:sldId xmlns:r="http://schemas.openxmlformats.org/officeDocument/2006/relationships" id="260" r:id="Rbc82143294cb4839"/>
-    <p:sldId xmlns:r="http://schemas.openxmlformats.org/officeDocument/2006/relationships" id="261" r:id="Rd5e36c9d67604c59"/>
-    <p:sldId xmlns:r="http://schemas.openxmlformats.org/officeDocument/2006/relationships" id="262" r:id="Rc4ccf08f13f74994"/>
-    <p:sldId xmlns:r="http://schemas.openxmlformats.org/officeDocument/2006/relationships" id="263" r:id="R7ead8fcfd9524145"/>
-    <p:sldId xmlns:r="http://schemas.openxmlformats.org/officeDocument/2006/relationships" id="264" r:id="R2d1d6e82fd5744c7"/>
-    <p:sldId xmlns:r="http://schemas.openxmlformats.org/officeDocument/2006/relationships" id="265" r:id="R26e0853d366b4089"/>
-    <p:sldId xmlns:r="http://schemas.openxmlformats.org/officeDocument/2006/relationships" id="266" r:id="R568caeb7eff64da4"/>
-    <p:sldId xmlns:r="http://schemas.openxmlformats.org/officeDocument/2006/relationships" id="267" r:id="R320c5ded5b454226"/>
-    <p:sldId xmlns:r="http://schemas.openxmlformats.org/officeDocument/2006/relationships" id="268" r:id="Rf7c6f1828ed941d9"/>
-    <p:sldId xmlns:r="http://schemas.openxmlformats.org/officeDocument/2006/relationships" id="269" r:id="R47bdec06b1304658"/>
-    <p:sldId xmlns:r="http://schemas.openxmlformats.org/officeDocument/2006/relationships" id="270" r:id="R75640052108d482a"/>
-    <p:sldId xmlns:r="http://schemas.openxmlformats.org/officeDocument/2006/relationships" id="271" r:id="Rbef2e080a01542a3"/>
-    <p:sldId xmlns:r="http://schemas.openxmlformats.org/officeDocument/2006/relationships" id="272" r:id="R155d9c52ce704eff"/>
-    <p:sldId xmlns:r="http://schemas.openxmlformats.org/officeDocument/2006/relationships" id="273" r:id="Rf76d427803854461"/>
-    <p:sldId xmlns:r="http://schemas.openxmlformats.org/officeDocument/2006/relationships" id="274" r:id="Raa99ad132cad47bc"/>
+    <p:sldId xmlns:r="http://schemas.openxmlformats.org/officeDocument/2006/relationships" id="256" r:id="R9de39235424a4ba9"/>
+    <p:sldId xmlns:r="http://schemas.openxmlformats.org/officeDocument/2006/relationships" id="257" r:id="Reb26291540ef41ee"/>
+    <p:sldId xmlns:r="http://schemas.openxmlformats.org/officeDocument/2006/relationships" id="258" r:id="Rf976b98b01fa4b73"/>
+    <p:sldId xmlns:r="http://schemas.openxmlformats.org/officeDocument/2006/relationships" id="259" r:id="Rc1d79ec7132f47fe"/>
+    <p:sldId xmlns:r="http://schemas.openxmlformats.org/officeDocument/2006/relationships" id="260" r:id="R5d8f8f1485d746e2"/>
+    <p:sldId xmlns:r="http://schemas.openxmlformats.org/officeDocument/2006/relationships" id="261" r:id="R0b5b65b570704f20"/>
+    <p:sldId xmlns:r="http://schemas.openxmlformats.org/officeDocument/2006/relationships" id="262" r:id="R1ebd2fb2d87742fe"/>
+    <p:sldId xmlns:r="http://schemas.openxmlformats.org/officeDocument/2006/relationships" id="263" r:id="R2b29c86c51084763"/>
+    <p:sldId xmlns:r="http://schemas.openxmlformats.org/officeDocument/2006/relationships" id="264" r:id="Rf89e0784e833454d"/>
+    <p:sldId xmlns:r="http://schemas.openxmlformats.org/officeDocument/2006/relationships" id="265" r:id="R618d3cb9d9d5490c"/>
+    <p:sldId xmlns:r="http://schemas.openxmlformats.org/officeDocument/2006/relationships" id="266" r:id="R1007bd6565844e6d"/>
+    <p:sldId xmlns:r="http://schemas.openxmlformats.org/officeDocument/2006/relationships" id="267" r:id="R02645d6864854d2b"/>
+    <p:sldId xmlns:r="http://schemas.openxmlformats.org/officeDocument/2006/relationships" id="268" r:id="R20d60d32e7eb476f"/>
+    <p:sldId xmlns:r="http://schemas.openxmlformats.org/officeDocument/2006/relationships" id="269" r:id="Ra517136c39494101"/>
+    <p:sldId xmlns:r="http://schemas.openxmlformats.org/officeDocument/2006/relationships" id="270" r:id="R976c1bebdaf84f67"/>
+    <p:sldId xmlns:r="http://schemas.openxmlformats.org/officeDocument/2006/relationships" id="271" r:id="R6caea55c96cc4aab"/>
+    <p:sldId xmlns:r="http://schemas.openxmlformats.org/officeDocument/2006/relationships" id="272" r:id="R12dbced84c21438c"/>
+    <p:sldId xmlns:r="http://schemas.openxmlformats.org/officeDocument/2006/relationships" id="273" r:id="R4ab0f3d17347427b"/>
+    <p:sldId xmlns:r="http://schemas.openxmlformats.org/officeDocument/2006/relationships" id="274" r:id="Re75c10d96fd548c7"/>
   </p:sldIdLst>
   <p:sldSz cx="12192000" cy="6858000"/>
   <p:notesSz cx="6858000" cy="9144000"/>
@@ -2193,7 +2193,7 @@
   </p:cSld>
   <p:clrMap bg1="lt1" tx1="dk1" bg2="lt2" tx2="dk2" accent1="accent1" accent2="accent2" accent3="accent3" accent4="accent4" accent5="accent5" accent6="accent6" hlink="hlink" folHlink="folHlink"/>
   <p:sldLayoutIdLst>
-    <p:sldLayoutId xmlns:r="http://schemas.openxmlformats.org/officeDocument/2006/relationships" id="2147483649" r:id="R5a1f6f69d0b94611"/>
+    <p:sldLayoutId xmlns:r="http://schemas.openxmlformats.org/officeDocument/2006/relationships" id="2147483649" r:id="Rd010f3d55ef542bf"/>
   </p:sldLayoutIdLst>
   <p:txStyles>
     <p:titleStyle>
@@ -2744,7 +2744,7 @@
           <p:cNvPr id="6" name="deck-supertitle">
             <a:extLst xmlns:a="http://schemas.openxmlformats.org/drawingml/2006/main">
               <a:ext uri="{FF2B5EF4-FFF2-40B4-BE49-F238E27FC236}">
-                <a16:creationId xmlns:a16="http://schemas.microsoft.com/office/drawing/2014/main" id="{559B9AA3-4D4C-426A-81CF-B09B9829A19B}"/>
+                <a16:creationId xmlns:a16="http://schemas.microsoft.com/office/drawing/2014/main" id="{41A1145E-AD30-4AF1-B68F-387E718A539A}"/>
               </a:ext>
             </a:extLst>
           </p:cNvPr>
@@ -2806,7 +2806,7 @@
           <p:cNvPr id="2" name="deck-title">
             <a:extLst xmlns:a="http://schemas.openxmlformats.org/drawingml/2006/main">
               <a:ext uri="{FF2B5EF4-FFF2-40B4-BE49-F238E27FC236}">
-                <a16:creationId xmlns:a16="http://schemas.microsoft.com/office/drawing/2014/main" id="{421DD16B-BBD4-4381-B103-9E020BEDE4B2}"/>
+                <a16:creationId xmlns:a16="http://schemas.microsoft.com/office/drawing/2014/main" id="{EE8E42AD-5347-45DB-87C8-F7C1D779DD5B}"/>
               </a:ext>
             </a:extLst>
           </p:cNvPr>
@@ -2868,7 +2868,7 @@
           <p:cNvPr id="3" name="deck-subtitle">
             <a:extLst xmlns:a="http://schemas.openxmlformats.org/drawingml/2006/main">
               <a:ext uri="{FF2B5EF4-FFF2-40B4-BE49-F238E27FC236}">
-                <a16:creationId xmlns:a16="http://schemas.microsoft.com/office/drawing/2014/main" id="{BE060271-4DD7-4E6E-8100-DBDE6A1E0EA7}"/>
+                <a16:creationId xmlns:a16="http://schemas.microsoft.com/office/drawing/2014/main" id="{7D24AC12-FEE2-43FA-83BB-69DE0C405C90}"/>
               </a:ext>
             </a:extLst>
           </p:cNvPr>
@@ -2930,7 +2930,7 @@
           <p:cNvPr id="4" name="title-field">
             <a:extLst xmlns:a="http://schemas.openxmlformats.org/drawingml/2006/main">
               <a:ext uri="{FF2B5EF4-FFF2-40B4-BE49-F238E27FC236}">
-                <a16:creationId xmlns:a16="http://schemas.microsoft.com/office/drawing/2014/main" id="{5CFC464A-26A7-447E-9532-232BF95158B3}"/>
+                <a16:creationId xmlns:a16="http://schemas.microsoft.com/office/drawing/2014/main" id="{B213A482-F787-4D17-8B68-EA082EC6EF16}"/>
               </a:ext>
             </a:extLst>
           </p:cNvPr>
@@ -2961,7 +2961,7 @@
           <p:cNvPr id="5" name="deck-number">
             <a:extLst xmlns:a="http://schemas.openxmlformats.org/drawingml/2006/main">
               <a:ext uri="{FF2B5EF4-FFF2-40B4-BE49-F238E27FC236}">
-                <a16:creationId xmlns:a16="http://schemas.microsoft.com/office/drawing/2014/main" id="{86789468-3AFB-4289-8AC9-417C3502D8AF}"/>
+                <a16:creationId xmlns:a16="http://schemas.microsoft.com/office/drawing/2014/main" id="{F041710A-141D-4F20-8319-D26D2BA24B43}"/>
               </a:ext>
             </a:extLst>
           </p:cNvPr>
@@ -3021,7 +3021,7 @@
     </p:spTree>
     <p:extLst>
       <p:ext uri="{BB962C8B-B14F-4D97-AF65-F5344CB8AC3E}">
-        <p14:creationId xmlns:p14="http://schemas.microsoft.com/office/powerpoint/2010/main" val="1245838415"/>
+        <p14:creationId xmlns:p14="http://schemas.microsoft.com/office/powerpoint/2010/main" val="1536713857"/>
       </p:ext>
     </p:extLst>
   </p:cSld>
@@ -3052,7 +3052,7 @@
           <p:cNvPr id="27" name="chapter-label">
             <a:extLst xmlns:a="http://schemas.openxmlformats.org/drawingml/2006/main">
               <a:ext uri="{FF2B5EF4-FFF2-40B4-BE49-F238E27FC236}">
-                <a16:creationId xmlns:a16="http://schemas.microsoft.com/office/drawing/2014/main" id="{99CC289F-EF3E-4337-89DF-21FCCEF7108C}"/>
+                <a16:creationId xmlns:a16="http://schemas.microsoft.com/office/drawing/2014/main" id="{AB6EF2F9-54F5-4585-A5EC-3E0366DF6209}"/>
               </a:ext>
             </a:extLst>
           </p:cNvPr>
@@ -3114,7 +3114,7 @@
           <p:cNvPr id="2" name="slide-title">
             <a:extLst xmlns:a="http://schemas.openxmlformats.org/drawingml/2006/main">
               <a:ext uri="{FF2B5EF4-FFF2-40B4-BE49-F238E27FC236}">
-                <a16:creationId xmlns:a16="http://schemas.microsoft.com/office/drawing/2014/main" id="{F2F37557-DD07-4533-BB23-BBF6555E049F}"/>
+                <a16:creationId xmlns:a16="http://schemas.microsoft.com/office/drawing/2014/main" id="{FF31AF31-79A3-4441-B4E6-35EAC9A88C20}"/>
               </a:ext>
             </a:extLst>
           </p:cNvPr>
@@ -3176,7 +3176,7 @@
           <p:cNvPr id="3" name="footer-rule">
             <a:extLst xmlns:a="http://schemas.openxmlformats.org/drawingml/2006/main">
               <a:ext uri="{FF2B5EF4-FFF2-40B4-BE49-F238E27FC236}">
-                <a16:creationId xmlns:a16="http://schemas.microsoft.com/office/drawing/2014/main" id="{63362747-BB35-4C07-9D52-65B649E076E4}"/>
+                <a16:creationId xmlns:a16="http://schemas.microsoft.com/office/drawing/2014/main" id="{CD670E38-0E92-4C7F-8196-9BC24CC4DD34}"/>
               </a:ext>
             </a:extLst>
           </p:cNvPr>
@@ -3207,7 +3207,7 @@
           <p:cNvPr id="4" name="footer-book">
             <a:extLst xmlns:a="http://schemas.openxmlformats.org/drawingml/2006/main">
               <a:ext uri="{FF2B5EF4-FFF2-40B4-BE49-F238E27FC236}">
-                <a16:creationId xmlns:a16="http://schemas.microsoft.com/office/drawing/2014/main" id="{FC1BD2D1-5177-4DF1-B151-09167F268D50}"/>
+                <a16:creationId xmlns:a16="http://schemas.microsoft.com/office/drawing/2014/main" id="{177510C4-4B29-4013-8C5B-30133EB4C9C3}"/>
               </a:ext>
             </a:extLst>
           </p:cNvPr>
@@ -3269,7 +3269,7 @@
           <p:cNvPr id="5" name="footer-number">
             <a:extLst xmlns:a="http://schemas.openxmlformats.org/drawingml/2006/main">
               <a:ext uri="{FF2B5EF4-FFF2-40B4-BE49-F238E27FC236}">
-                <a16:creationId xmlns:a16="http://schemas.microsoft.com/office/drawing/2014/main" id="{269952DD-BE59-499B-8B18-D2E7C5ECC1BD}"/>
+                <a16:creationId xmlns:a16="http://schemas.microsoft.com/office/drawing/2014/main" id="{4173A185-3CB4-4A74-BF3F-907E26D8E111}"/>
               </a:ext>
             </a:extLst>
           </p:cNvPr>
@@ -3331,7 +3331,7 @@
           <p:cNvPr id="6" name="">
             <a:extLst xmlns:a="http://schemas.openxmlformats.org/drawingml/2006/main">
               <a:ext uri="{FF2B5EF4-FFF2-40B4-BE49-F238E27FC236}">
-                <a16:creationId xmlns:a16="http://schemas.microsoft.com/office/drawing/2014/main" id="{00C3A30C-DE0A-432F-953F-B118B90C5BC7}"/>
+                <a16:creationId xmlns:a16="http://schemas.microsoft.com/office/drawing/2014/main" id="{A897DC56-E5EF-467D-BEA0-A094EE794F62}"/>
               </a:ext>
             </a:extLst>
           </p:cNvPr>
@@ -3393,7 +3393,7 @@
           <p:cNvPr id="7" name="step-rule-1">
             <a:extLst xmlns:a="http://schemas.openxmlformats.org/drawingml/2006/main">
               <a:ext uri="{FF2B5EF4-FFF2-40B4-BE49-F238E27FC236}">
-                <a16:creationId xmlns:a16="http://schemas.microsoft.com/office/drawing/2014/main" id="{F53AF53E-E638-4B30-894D-05DFA8A98932}"/>
+                <a16:creationId xmlns:a16="http://schemas.microsoft.com/office/drawing/2014/main" id="{944B8455-7C95-46D3-BFB2-1B6FE0F66C4D}"/>
               </a:ext>
             </a:extLst>
           </p:cNvPr>
@@ -3424,7 +3424,7 @@
           <p:cNvPr id="8" name="">
             <a:extLst xmlns:a="http://schemas.openxmlformats.org/drawingml/2006/main">
               <a:ext uri="{FF2B5EF4-FFF2-40B4-BE49-F238E27FC236}">
-                <a16:creationId xmlns:a16="http://schemas.microsoft.com/office/drawing/2014/main" id="{A0B0231A-4259-407E-AD16-11CCC5CE31A0}"/>
+                <a16:creationId xmlns:a16="http://schemas.microsoft.com/office/drawing/2014/main" id="{B02DE700-1BC4-4125-9AA3-8370AB43E044}"/>
               </a:ext>
             </a:extLst>
           </p:cNvPr>
@@ -3486,7 +3486,7 @@
           <p:cNvPr id="9" name="">
             <a:extLst xmlns:a="http://schemas.openxmlformats.org/drawingml/2006/main">
               <a:ext uri="{FF2B5EF4-FFF2-40B4-BE49-F238E27FC236}">
-                <a16:creationId xmlns:a16="http://schemas.microsoft.com/office/drawing/2014/main" id="{752C8D66-4EA9-42DE-9B48-D921F5DB1CA0}"/>
+                <a16:creationId xmlns:a16="http://schemas.microsoft.com/office/drawing/2014/main" id="{7325B7F8-232B-463C-AB54-653B8807607F}"/>
               </a:ext>
             </a:extLst>
           </p:cNvPr>
@@ -3548,7 +3548,7 @@
           <p:cNvPr id="10" name="">
             <a:extLst xmlns:a="http://schemas.openxmlformats.org/drawingml/2006/main">
               <a:ext uri="{FF2B5EF4-FFF2-40B4-BE49-F238E27FC236}">
-                <a16:creationId xmlns:a16="http://schemas.microsoft.com/office/drawing/2014/main" id="{9BC06A0F-A6B2-4C42-AD26-FD68AC5A9606}"/>
+                <a16:creationId xmlns:a16="http://schemas.microsoft.com/office/drawing/2014/main" id="{07B7F835-9ADC-45E0-B13F-342E9BD52009}"/>
               </a:ext>
             </a:extLst>
           </p:cNvPr>
@@ -3610,7 +3610,7 @@
           <p:cNvPr id="11" name="step-rule-2">
             <a:extLst xmlns:a="http://schemas.openxmlformats.org/drawingml/2006/main">
               <a:ext uri="{FF2B5EF4-FFF2-40B4-BE49-F238E27FC236}">
-                <a16:creationId xmlns:a16="http://schemas.microsoft.com/office/drawing/2014/main" id="{0E23F6C3-6978-436A-8387-F9C5FA49C05C}"/>
+                <a16:creationId xmlns:a16="http://schemas.microsoft.com/office/drawing/2014/main" id="{1C07BD19-ADE3-4037-9F50-81AD03C46AD6}"/>
               </a:ext>
             </a:extLst>
           </p:cNvPr>
@@ -3641,7 +3641,7 @@
           <p:cNvPr id="12" name="">
             <a:extLst xmlns:a="http://schemas.openxmlformats.org/drawingml/2006/main">
               <a:ext uri="{FF2B5EF4-FFF2-40B4-BE49-F238E27FC236}">
-                <a16:creationId xmlns:a16="http://schemas.microsoft.com/office/drawing/2014/main" id="{1F930374-405E-4A82-A694-37F42CA770DA}"/>
+                <a16:creationId xmlns:a16="http://schemas.microsoft.com/office/drawing/2014/main" id="{1365F5FA-8D24-4DB3-ABDB-7F3C0019F54C}"/>
               </a:ext>
             </a:extLst>
           </p:cNvPr>
@@ -3703,7 +3703,7 @@
           <p:cNvPr id="13" name="">
             <a:extLst xmlns:a="http://schemas.openxmlformats.org/drawingml/2006/main">
               <a:ext uri="{FF2B5EF4-FFF2-40B4-BE49-F238E27FC236}">
-                <a16:creationId xmlns:a16="http://schemas.microsoft.com/office/drawing/2014/main" id="{EA2BAC4D-36A8-4BDE-BDEE-7D3C0782C9DC}"/>
+                <a16:creationId xmlns:a16="http://schemas.microsoft.com/office/drawing/2014/main" id="{B62F6956-012D-48F8-9BC2-3298F386D588}"/>
               </a:ext>
             </a:extLst>
           </p:cNvPr>
@@ -3765,7 +3765,7 @@
           <p:cNvPr id="14" name="">
             <a:extLst xmlns:a="http://schemas.openxmlformats.org/drawingml/2006/main">
               <a:ext uri="{FF2B5EF4-FFF2-40B4-BE49-F238E27FC236}">
-                <a16:creationId xmlns:a16="http://schemas.microsoft.com/office/drawing/2014/main" id="{111668C6-E7D5-4661-8B4E-9A8FBD9DEDAA}"/>
+                <a16:creationId xmlns:a16="http://schemas.microsoft.com/office/drawing/2014/main" id="{2C394A92-9794-4417-9142-E9BB6C87C890}"/>
               </a:ext>
             </a:extLst>
           </p:cNvPr>
@@ -3827,7 +3827,7 @@
           <p:cNvPr id="15" name="step-rule-3">
             <a:extLst xmlns:a="http://schemas.openxmlformats.org/drawingml/2006/main">
               <a:ext uri="{FF2B5EF4-FFF2-40B4-BE49-F238E27FC236}">
-                <a16:creationId xmlns:a16="http://schemas.microsoft.com/office/drawing/2014/main" id="{24EEE08E-596E-47BA-A5A9-1273073255B8}"/>
+                <a16:creationId xmlns:a16="http://schemas.microsoft.com/office/drawing/2014/main" id="{75EDB2E7-ECDD-491B-A84C-F7DCEC02B845}"/>
               </a:ext>
             </a:extLst>
           </p:cNvPr>
@@ -3858,7 +3858,7 @@
           <p:cNvPr id="16" name="">
             <a:extLst xmlns:a="http://schemas.openxmlformats.org/drawingml/2006/main">
               <a:ext uri="{FF2B5EF4-FFF2-40B4-BE49-F238E27FC236}">
-                <a16:creationId xmlns:a16="http://schemas.microsoft.com/office/drawing/2014/main" id="{9DCACA33-74F9-4A98-BE30-ED7B6D4E6C73}"/>
+                <a16:creationId xmlns:a16="http://schemas.microsoft.com/office/drawing/2014/main" id="{E474A5EA-2A9E-45ED-96BF-F01C36B10323}"/>
               </a:ext>
             </a:extLst>
           </p:cNvPr>
@@ -3920,7 +3920,7 @@
           <p:cNvPr id="17" name="">
             <a:extLst xmlns:a="http://schemas.openxmlformats.org/drawingml/2006/main">
               <a:ext uri="{FF2B5EF4-FFF2-40B4-BE49-F238E27FC236}">
-                <a16:creationId xmlns:a16="http://schemas.microsoft.com/office/drawing/2014/main" id="{B4B06BC0-02CB-4EDD-8AA6-2A43759A990A}"/>
+                <a16:creationId xmlns:a16="http://schemas.microsoft.com/office/drawing/2014/main" id="{1653FD37-9D8A-406F-83A0-1D009BA35DCD}"/>
               </a:ext>
             </a:extLst>
           </p:cNvPr>
@@ -3982,7 +3982,7 @@
           <p:cNvPr id="18" name="">
             <a:extLst xmlns:a="http://schemas.openxmlformats.org/drawingml/2006/main">
               <a:ext uri="{FF2B5EF4-FFF2-40B4-BE49-F238E27FC236}">
-                <a16:creationId xmlns:a16="http://schemas.microsoft.com/office/drawing/2014/main" id="{ACF90425-9C0C-4D6D-8CFB-A5F1DE7CC522}"/>
+                <a16:creationId xmlns:a16="http://schemas.microsoft.com/office/drawing/2014/main" id="{C226FB18-1AB6-48CE-BA18-5326D34A724D}"/>
               </a:ext>
             </a:extLst>
           </p:cNvPr>
@@ -4044,7 +4044,7 @@
           <p:cNvPr id="19" name="step-rule-4">
             <a:extLst xmlns:a="http://schemas.openxmlformats.org/drawingml/2006/main">
               <a:ext uri="{FF2B5EF4-FFF2-40B4-BE49-F238E27FC236}">
-                <a16:creationId xmlns:a16="http://schemas.microsoft.com/office/drawing/2014/main" id="{C3AC5FD6-1E7D-4C6B-827F-58E7D49039FD}"/>
+                <a16:creationId xmlns:a16="http://schemas.microsoft.com/office/drawing/2014/main" id="{3416C8AD-979A-4854-B649-0C02E6FA471F}"/>
               </a:ext>
             </a:extLst>
           </p:cNvPr>
@@ -4075,7 +4075,7 @@
           <p:cNvPr id="20" name="">
             <a:extLst xmlns:a="http://schemas.openxmlformats.org/drawingml/2006/main">
               <a:ext uri="{FF2B5EF4-FFF2-40B4-BE49-F238E27FC236}">
-                <a16:creationId xmlns:a16="http://schemas.microsoft.com/office/drawing/2014/main" id="{89C08594-9E10-4082-B064-B9540C3938A2}"/>
+                <a16:creationId xmlns:a16="http://schemas.microsoft.com/office/drawing/2014/main" id="{691DE914-979A-4A0F-BFB8-8D2FDEE9462B}"/>
               </a:ext>
             </a:extLst>
           </p:cNvPr>
@@ -4137,7 +4137,7 @@
           <p:cNvPr id="21" name="">
             <a:extLst xmlns:a="http://schemas.openxmlformats.org/drawingml/2006/main">
               <a:ext uri="{FF2B5EF4-FFF2-40B4-BE49-F238E27FC236}">
-                <a16:creationId xmlns:a16="http://schemas.microsoft.com/office/drawing/2014/main" id="{CD9D2AFA-FFBE-4CED-9EBB-E8ABC9945B72}"/>
+                <a16:creationId xmlns:a16="http://schemas.microsoft.com/office/drawing/2014/main" id="{D9DA1E5C-D7DE-4470-9865-08EAC1741829}"/>
               </a:ext>
             </a:extLst>
           </p:cNvPr>
@@ -4199,7 +4199,7 @@
           <p:cNvPr id="22" name="">
             <a:extLst xmlns:a="http://schemas.openxmlformats.org/drawingml/2006/main">
               <a:ext uri="{FF2B5EF4-FFF2-40B4-BE49-F238E27FC236}">
-                <a16:creationId xmlns:a16="http://schemas.microsoft.com/office/drawing/2014/main" id="{E5B42E64-EE58-4F37-9599-61C5AF26DACE}"/>
+                <a16:creationId xmlns:a16="http://schemas.microsoft.com/office/drawing/2014/main" id="{2B4708FA-5C2A-4C00-9DB6-74633900238F}"/>
               </a:ext>
             </a:extLst>
           </p:cNvPr>
@@ -4261,7 +4261,7 @@
           <p:cNvPr id="23" name="step-rule-5">
             <a:extLst xmlns:a="http://schemas.openxmlformats.org/drawingml/2006/main">
               <a:ext uri="{FF2B5EF4-FFF2-40B4-BE49-F238E27FC236}">
-                <a16:creationId xmlns:a16="http://schemas.microsoft.com/office/drawing/2014/main" id="{25A4499F-0530-47A1-AA6B-DE42F264C136}"/>
+                <a16:creationId xmlns:a16="http://schemas.microsoft.com/office/drawing/2014/main" id="{B80BF25D-1C51-47AB-816A-E5FAD043CED4}"/>
               </a:ext>
             </a:extLst>
           </p:cNvPr>
@@ -4292,7 +4292,7 @@
           <p:cNvPr id="24" name="">
             <a:extLst xmlns:a="http://schemas.openxmlformats.org/drawingml/2006/main">
               <a:ext uri="{FF2B5EF4-FFF2-40B4-BE49-F238E27FC236}">
-                <a16:creationId xmlns:a16="http://schemas.microsoft.com/office/drawing/2014/main" id="{15874244-4DD6-4A3A-8007-A60527C3066A}"/>
+                <a16:creationId xmlns:a16="http://schemas.microsoft.com/office/drawing/2014/main" id="{4DAB4C8B-9B10-4385-8F7E-19C73FD9148C}"/>
               </a:ext>
             </a:extLst>
           </p:cNvPr>
@@ -4354,7 +4354,7 @@
           <p:cNvPr id="25" name="">
             <a:extLst xmlns:a="http://schemas.openxmlformats.org/drawingml/2006/main">
               <a:ext uri="{FF2B5EF4-FFF2-40B4-BE49-F238E27FC236}">
-                <a16:creationId xmlns:a16="http://schemas.microsoft.com/office/drawing/2014/main" id="{D48B5619-D106-4F37-BB8C-28871B1CB011}"/>
+                <a16:creationId xmlns:a16="http://schemas.microsoft.com/office/drawing/2014/main" id="{41E0D9BE-07F1-46FD-8545-71B8B53F0B82}"/>
               </a:ext>
             </a:extLst>
           </p:cNvPr>
@@ -4416,7 +4416,7 @@
           <p:cNvPr id="26" name="">
             <a:extLst xmlns:a="http://schemas.openxmlformats.org/drawingml/2006/main">
               <a:ext uri="{FF2B5EF4-FFF2-40B4-BE49-F238E27FC236}">
-                <a16:creationId xmlns:a16="http://schemas.microsoft.com/office/drawing/2014/main" id="{9CE12E32-3244-4CBC-96D4-E6D3AA0497F0}"/>
+                <a16:creationId xmlns:a16="http://schemas.microsoft.com/office/drawing/2014/main" id="{AC3F3CFB-128F-4D7F-92C9-4284EF254426}"/>
               </a:ext>
             </a:extLst>
           </p:cNvPr>
@@ -4476,7 +4476,7 @@
     </p:spTree>
     <p:extLst>
       <p:ext uri="{BB962C8B-B14F-4D97-AF65-F5344CB8AC3E}">
-        <p14:creationId xmlns:p14="http://schemas.microsoft.com/office/powerpoint/2010/main" val="1808309332"/>
+        <p14:creationId xmlns:p14="http://schemas.microsoft.com/office/powerpoint/2010/main" val="1146170220"/>
       </p:ext>
     </p:extLst>
   </p:cSld>
@@ -4507,7 +4507,7 @@
           <p:cNvPr id="8" name="chapter-label">
             <a:extLst xmlns:a="http://schemas.openxmlformats.org/drawingml/2006/main">
               <a:ext uri="{FF2B5EF4-FFF2-40B4-BE49-F238E27FC236}">
-                <a16:creationId xmlns:a16="http://schemas.microsoft.com/office/drawing/2014/main" id="{2C469759-E08C-42E4-BE57-193E530CF70C}"/>
+                <a16:creationId xmlns:a16="http://schemas.microsoft.com/office/drawing/2014/main" id="{AE644C5F-61A5-4301-A6F0-D20E5D55E6C3}"/>
               </a:ext>
             </a:extLst>
           </p:cNvPr>
@@ -4569,7 +4569,7 @@
           <p:cNvPr id="2" name="slide-title">
             <a:extLst xmlns:a="http://schemas.openxmlformats.org/drawingml/2006/main">
               <a:ext uri="{FF2B5EF4-FFF2-40B4-BE49-F238E27FC236}">
-                <a16:creationId xmlns:a16="http://schemas.microsoft.com/office/drawing/2014/main" id="{D07ADCED-6B90-414F-B181-A971A7BB7C39}"/>
+                <a16:creationId xmlns:a16="http://schemas.microsoft.com/office/drawing/2014/main" id="{B191A420-740F-492D-A4C4-FF4386A89FD8}"/>
               </a:ext>
             </a:extLst>
           </p:cNvPr>
@@ -4631,7 +4631,7 @@
           <p:cNvPr id="3" name="footer-rule">
             <a:extLst xmlns:a="http://schemas.openxmlformats.org/drawingml/2006/main">
               <a:ext uri="{FF2B5EF4-FFF2-40B4-BE49-F238E27FC236}">
-                <a16:creationId xmlns:a16="http://schemas.microsoft.com/office/drawing/2014/main" id="{99D74D05-F0D0-447A-A2FA-1E70BE763DF5}"/>
+                <a16:creationId xmlns:a16="http://schemas.microsoft.com/office/drawing/2014/main" id="{82D238D4-2DE8-450F-8EDA-0A701DB364B1}"/>
               </a:ext>
             </a:extLst>
           </p:cNvPr>
@@ -4662,7 +4662,7 @@
           <p:cNvPr id="4" name="footer-book">
             <a:extLst xmlns:a="http://schemas.openxmlformats.org/drawingml/2006/main">
               <a:ext uri="{FF2B5EF4-FFF2-40B4-BE49-F238E27FC236}">
-                <a16:creationId xmlns:a16="http://schemas.microsoft.com/office/drawing/2014/main" id="{D96371DB-F455-477B-805A-5D6F88751533}"/>
+                <a16:creationId xmlns:a16="http://schemas.microsoft.com/office/drawing/2014/main" id="{3C324F8A-7FBD-46D6-ADCF-6CC5FF78DF5B}"/>
               </a:ext>
             </a:extLst>
           </p:cNvPr>
@@ -4724,7 +4724,7 @@
           <p:cNvPr id="5" name="footer-number">
             <a:extLst xmlns:a="http://schemas.openxmlformats.org/drawingml/2006/main">
               <a:ext uri="{FF2B5EF4-FFF2-40B4-BE49-F238E27FC236}">
-                <a16:creationId xmlns:a16="http://schemas.microsoft.com/office/drawing/2014/main" id="{F49F63FC-7D0A-4982-82C9-48F40DEC2425}"/>
+                <a16:creationId xmlns:a16="http://schemas.microsoft.com/office/drawing/2014/main" id="{D58020E3-D4F7-4E01-AEAA-864CBE4679D5}"/>
               </a:ext>
             </a:extLst>
           </p:cNvPr>
@@ -4790,7 +4790,7 @@
           <p:nvPr/>
         </p:nvPicPr>
         <p:blipFill>
-          <a:blip xmlns:r="http://schemas.openxmlformats.org/officeDocument/2006/relationships" xmlns:a="http://schemas.openxmlformats.org/drawingml/2006/main" r:embed="R0e85c0858827406b"/>
+          <a:blip xmlns:r="http://schemas.openxmlformats.org/officeDocument/2006/relationships" xmlns:a="http://schemas.openxmlformats.org/drawingml/2006/main" r:embed="R5d700256043549ab"/>
           <a:stretch xmlns:a="http://schemas.openxmlformats.org/drawingml/2006/main"/>
         </p:blipFill>
         <p:spPr>
@@ -4808,7 +4808,7 @@
           <p:cNvPr id="7" name="">
             <a:extLst xmlns:a="http://schemas.openxmlformats.org/drawingml/2006/main">
               <a:ext uri="{FF2B5EF4-FFF2-40B4-BE49-F238E27FC236}">
-                <a16:creationId xmlns:a16="http://schemas.microsoft.com/office/drawing/2014/main" id="{09C7F84C-FAE9-4D8C-B155-286FA61AF61C}"/>
+                <a16:creationId xmlns:a16="http://schemas.microsoft.com/office/drawing/2014/main" id="{0903D590-F660-4923-A95E-F890884B11A8}"/>
               </a:ext>
             </a:extLst>
           </p:cNvPr>
@@ -4868,7 +4868,7 @@
     </p:spTree>
     <p:extLst>
       <p:ext uri="{BB962C8B-B14F-4D97-AF65-F5344CB8AC3E}">
-        <p14:creationId xmlns:p14="http://schemas.microsoft.com/office/powerpoint/2010/main" val="1899193077"/>
+        <p14:creationId xmlns:p14="http://schemas.microsoft.com/office/powerpoint/2010/main" val="528562741"/>
       </p:ext>
     </p:extLst>
   </p:cSld>
@@ -4899,7 +4899,7 @@
           <p:cNvPr id="10" name="">
             <a:extLst xmlns:a="http://schemas.openxmlformats.org/drawingml/2006/main">
               <a:ext uri="{FF2B5EF4-FFF2-40B4-BE49-F238E27FC236}">
-                <a16:creationId xmlns:a16="http://schemas.microsoft.com/office/drawing/2014/main" id="{A4D1163F-5606-47BA-AA79-9D662F5C9103}"/>
+                <a16:creationId xmlns:a16="http://schemas.microsoft.com/office/drawing/2014/main" id="{0FA482B9-DE14-40C4-ACD8-F757204D58FE}"/>
               </a:ext>
             </a:extLst>
           </p:cNvPr>
@@ -4961,7 +4961,7 @@
           <p:cNvPr id="2" name="">
             <a:extLst xmlns:a="http://schemas.openxmlformats.org/drawingml/2006/main">
               <a:ext uri="{FF2B5EF4-FFF2-40B4-BE49-F238E27FC236}">
-                <a16:creationId xmlns:a16="http://schemas.microsoft.com/office/drawing/2014/main" id="{CB0959F5-B9AE-48E8-8BC2-F4D07B075908}"/>
+                <a16:creationId xmlns:a16="http://schemas.microsoft.com/office/drawing/2014/main" id="{B36A98ED-1826-47F8-B31C-542DBD3A24DD}"/>
               </a:ext>
             </a:extLst>
           </p:cNvPr>
@@ -5023,7 +5023,7 @@
           <p:cNvPr id="3" name="big-statement">
             <a:extLst xmlns:a="http://schemas.openxmlformats.org/drawingml/2006/main">
               <a:ext uri="{FF2B5EF4-FFF2-40B4-BE49-F238E27FC236}">
-                <a16:creationId xmlns:a16="http://schemas.microsoft.com/office/drawing/2014/main" id="{A8228DD8-28ED-4508-BF0A-00B52AC62A59}"/>
+                <a16:creationId xmlns:a16="http://schemas.microsoft.com/office/drawing/2014/main" id="{E09DD06B-7A97-4DD4-8A03-C99DB1162408}"/>
               </a:ext>
             </a:extLst>
           </p:cNvPr>
@@ -5085,7 +5085,7 @@
           <p:cNvPr id="4" name="bullet-mark-1">
             <a:extLst xmlns:a="http://schemas.openxmlformats.org/drawingml/2006/main">
               <a:ext uri="{FF2B5EF4-FFF2-40B4-BE49-F238E27FC236}">
-                <a16:creationId xmlns:a16="http://schemas.microsoft.com/office/drawing/2014/main" id="{8B3637A7-7CCC-4A5F-8AE0-1D547DF73D86}"/>
+                <a16:creationId xmlns:a16="http://schemas.microsoft.com/office/drawing/2014/main" id="{ACAD9ED0-16EF-4E8F-9C45-E5573EB27694}"/>
               </a:ext>
             </a:extLst>
           </p:cNvPr>
@@ -5147,7 +5147,7 @@
           <p:cNvPr id="5" name="bullet-1">
             <a:extLst xmlns:a="http://schemas.openxmlformats.org/drawingml/2006/main">
               <a:ext uri="{FF2B5EF4-FFF2-40B4-BE49-F238E27FC236}">
-                <a16:creationId xmlns:a16="http://schemas.microsoft.com/office/drawing/2014/main" id="{CE78E34B-99D9-4797-BBE4-7874E891F870}"/>
+                <a16:creationId xmlns:a16="http://schemas.microsoft.com/office/drawing/2014/main" id="{9CDA6410-B284-4D7F-AB01-B8D7CBF9D3B4}"/>
               </a:ext>
             </a:extLst>
           </p:cNvPr>
@@ -5209,7 +5209,7 @@
           <p:cNvPr id="6" name="bullet-mark-2">
             <a:extLst xmlns:a="http://schemas.openxmlformats.org/drawingml/2006/main">
               <a:ext uri="{FF2B5EF4-FFF2-40B4-BE49-F238E27FC236}">
-                <a16:creationId xmlns:a16="http://schemas.microsoft.com/office/drawing/2014/main" id="{754E12FE-CAD4-4845-B943-C9092A227C8C}"/>
+                <a16:creationId xmlns:a16="http://schemas.microsoft.com/office/drawing/2014/main" id="{BFFAC4C4-F8BC-4340-BD37-BFE8166914F7}"/>
               </a:ext>
             </a:extLst>
           </p:cNvPr>
@@ -5271,7 +5271,7 @@
           <p:cNvPr id="7" name="bullet-2">
             <a:extLst xmlns:a="http://schemas.openxmlformats.org/drawingml/2006/main">
               <a:ext uri="{FF2B5EF4-FFF2-40B4-BE49-F238E27FC236}">
-                <a16:creationId xmlns:a16="http://schemas.microsoft.com/office/drawing/2014/main" id="{B104422F-9166-4B2B-9011-560A7B925FFC}"/>
+                <a16:creationId xmlns:a16="http://schemas.microsoft.com/office/drawing/2014/main" id="{6B7BC099-3559-4B03-8280-75826056FF20}"/>
               </a:ext>
             </a:extLst>
           </p:cNvPr>
@@ -5333,7 +5333,7 @@
           <p:cNvPr id="8" name="bullet-mark-3">
             <a:extLst xmlns:a="http://schemas.openxmlformats.org/drawingml/2006/main">
               <a:ext uri="{FF2B5EF4-FFF2-40B4-BE49-F238E27FC236}">
-                <a16:creationId xmlns:a16="http://schemas.microsoft.com/office/drawing/2014/main" id="{DCA7CF56-695D-499A-B23A-55C54D9B2573}"/>
+                <a16:creationId xmlns:a16="http://schemas.microsoft.com/office/drawing/2014/main" id="{27B74441-F3D9-498F-B152-D9D1B129EE95}"/>
               </a:ext>
             </a:extLst>
           </p:cNvPr>
@@ -5395,7 +5395,7 @@
           <p:cNvPr id="9" name="bullet-3">
             <a:extLst xmlns:a="http://schemas.openxmlformats.org/drawingml/2006/main">
               <a:ext uri="{FF2B5EF4-FFF2-40B4-BE49-F238E27FC236}">
-                <a16:creationId xmlns:a16="http://schemas.microsoft.com/office/drawing/2014/main" id="{12C2E630-3A54-4103-AE75-5D71DE169EC4}"/>
+                <a16:creationId xmlns:a16="http://schemas.microsoft.com/office/drawing/2014/main" id="{EDF20E9F-DBFE-4E2C-8879-8B122BA17615}"/>
               </a:ext>
             </a:extLst>
           </p:cNvPr>
@@ -5455,7 +5455,7 @@
     </p:spTree>
     <p:extLst>
       <p:ext uri="{BB962C8B-B14F-4D97-AF65-F5344CB8AC3E}">
-        <p14:creationId xmlns:p14="http://schemas.microsoft.com/office/powerpoint/2010/main" val="1195790266"/>
+        <p14:creationId xmlns:p14="http://schemas.microsoft.com/office/powerpoint/2010/main" val="1460864792"/>
       </p:ext>
     </p:extLst>
   </p:cSld>
@@ -5486,7 +5486,7 @@
           <p:cNvPr id="15" name="chapter-label">
             <a:extLst xmlns:a="http://schemas.openxmlformats.org/drawingml/2006/main">
               <a:ext uri="{FF2B5EF4-FFF2-40B4-BE49-F238E27FC236}">
-                <a16:creationId xmlns:a16="http://schemas.microsoft.com/office/drawing/2014/main" id="{AB2FF324-A2CB-4CD5-A801-11220C63E0D5}"/>
+                <a16:creationId xmlns:a16="http://schemas.microsoft.com/office/drawing/2014/main" id="{42A266E5-01EE-4902-9413-09187CA357FD}"/>
               </a:ext>
             </a:extLst>
           </p:cNvPr>
@@ -5548,7 +5548,7 @@
           <p:cNvPr id="2" name="slide-title">
             <a:extLst xmlns:a="http://schemas.openxmlformats.org/drawingml/2006/main">
               <a:ext uri="{FF2B5EF4-FFF2-40B4-BE49-F238E27FC236}">
-                <a16:creationId xmlns:a16="http://schemas.microsoft.com/office/drawing/2014/main" id="{0CB21787-093B-4536-BE9F-F6F5513FFA11}"/>
+                <a16:creationId xmlns:a16="http://schemas.microsoft.com/office/drawing/2014/main" id="{3D714DE4-1DF7-4DEC-A76A-12E00A8D0C4D}"/>
               </a:ext>
             </a:extLst>
           </p:cNvPr>
@@ -5610,7 +5610,7 @@
           <p:cNvPr id="3" name="footer-rule">
             <a:extLst xmlns:a="http://schemas.openxmlformats.org/drawingml/2006/main">
               <a:ext uri="{FF2B5EF4-FFF2-40B4-BE49-F238E27FC236}">
-                <a16:creationId xmlns:a16="http://schemas.microsoft.com/office/drawing/2014/main" id="{D026759E-DEAA-42B6-BC19-0FBB4FE4F99F}"/>
+                <a16:creationId xmlns:a16="http://schemas.microsoft.com/office/drawing/2014/main" id="{CFAB6207-97E1-4EE8-AA80-334D77830F9A}"/>
               </a:ext>
             </a:extLst>
           </p:cNvPr>
@@ -5641,7 +5641,7 @@
           <p:cNvPr id="4" name="footer-book">
             <a:extLst xmlns:a="http://schemas.openxmlformats.org/drawingml/2006/main">
               <a:ext uri="{FF2B5EF4-FFF2-40B4-BE49-F238E27FC236}">
-                <a16:creationId xmlns:a16="http://schemas.microsoft.com/office/drawing/2014/main" id="{5DA2D79D-126B-44BF-84F6-EAA0D0078071}"/>
+                <a16:creationId xmlns:a16="http://schemas.microsoft.com/office/drawing/2014/main" id="{0734692D-19BD-4F43-8BE3-1CB4E31433DB}"/>
               </a:ext>
             </a:extLst>
           </p:cNvPr>
@@ -5703,7 +5703,7 @@
           <p:cNvPr id="5" name="footer-number">
             <a:extLst xmlns:a="http://schemas.openxmlformats.org/drawingml/2006/main">
               <a:ext uri="{FF2B5EF4-FFF2-40B4-BE49-F238E27FC236}">
-                <a16:creationId xmlns:a16="http://schemas.microsoft.com/office/drawing/2014/main" id="{2377D262-FE6F-4598-9C1F-A5B0BAF4DD3C}"/>
+                <a16:creationId xmlns:a16="http://schemas.microsoft.com/office/drawing/2014/main" id="{386E0A77-7C49-4854-B70A-27B5516ECFB7}"/>
               </a:ext>
             </a:extLst>
           </p:cNvPr>
@@ -5765,7 +5765,7 @@
           <p:cNvPr id="6" name="panel-1">
             <a:extLst xmlns:a="http://schemas.openxmlformats.org/drawingml/2006/main">
               <a:ext uri="{FF2B5EF4-FFF2-40B4-BE49-F238E27FC236}">
-                <a16:creationId xmlns:a16="http://schemas.microsoft.com/office/drawing/2014/main" id="{C63629CE-1C53-4B1A-A30C-538370550B62}"/>
+                <a16:creationId xmlns:a16="http://schemas.microsoft.com/office/drawing/2014/main" id="{C80C031C-482C-4058-B7BC-5E01ABCEE30E}"/>
               </a:ext>
             </a:extLst>
           </p:cNvPr>
@@ -5798,7 +5798,7 @@
           <p:cNvPr id="7" name="">
             <a:extLst xmlns:a="http://schemas.openxmlformats.org/drawingml/2006/main">
               <a:ext uri="{FF2B5EF4-FFF2-40B4-BE49-F238E27FC236}">
-                <a16:creationId xmlns:a16="http://schemas.microsoft.com/office/drawing/2014/main" id="{81E6755D-AF23-47E8-BD80-E5AF2D45B825}"/>
+                <a16:creationId xmlns:a16="http://schemas.microsoft.com/office/drawing/2014/main" id="{AE987493-F23A-4724-B742-B50865D403BC}"/>
               </a:ext>
             </a:extLst>
           </p:cNvPr>
@@ -5860,7 +5860,7 @@
           <p:cNvPr id="8" name="">
             <a:extLst xmlns:a="http://schemas.openxmlformats.org/drawingml/2006/main">
               <a:ext uri="{FF2B5EF4-FFF2-40B4-BE49-F238E27FC236}">
-                <a16:creationId xmlns:a16="http://schemas.microsoft.com/office/drawing/2014/main" id="{F8EBED03-E3CD-4A36-91C9-19359FEBCBDE}"/>
+                <a16:creationId xmlns:a16="http://schemas.microsoft.com/office/drawing/2014/main" id="{3CF11B28-0055-4719-AD67-91A21B7BB081}"/>
               </a:ext>
             </a:extLst>
           </p:cNvPr>
@@ -5922,7 +5922,7 @@
           <p:cNvPr id="9" name="">
             <a:extLst xmlns:a="http://schemas.openxmlformats.org/drawingml/2006/main">
               <a:ext uri="{FF2B5EF4-FFF2-40B4-BE49-F238E27FC236}">
-                <a16:creationId xmlns:a16="http://schemas.microsoft.com/office/drawing/2014/main" id="{0B48A714-C73D-470D-9E84-0C103DA1DA17}"/>
+                <a16:creationId xmlns:a16="http://schemas.microsoft.com/office/drawing/2014/main" id="{0855AD4C-DF74-4644-8C18-42CAF58596B2}"/>
               </a:ext>
             </a:extLst>
           </p:cNvPr>
@@ -5984,7 +5984,7 @@
           <p:cNvPr id="10" name="panel-2">
             <a:extLst xmlns:a="http://schemas.openxmlformats.org/drawingml/2006/main">
               <a:ext uri="{FF2B5EF4-FFF2-40B4-BE49-F238E27FC236}">
-                <a16:creationId xmlns:a16="http://schemas.microsoft.com/office/drawing/2014/main" id="{B43FA1BF-A0C1-4EC0-957B-363E678F1D8A}"/>
+                <a16:creationId xmlns:a16="http://schemas.microsoft.com/office/drawing/2014/main" id="{6339C14E-B2E5-4026-8DBB-AED3CC22DA4A}"/>
               </a:ext>
             </a:extLst>
           </p:cNvPr>
@@ -6017,7 +6017,7 @@
           <p:cNvPr id="11" name="">
             <a:extLst xmlns:a="http://schemas.openxmlformats.org/drawingml/2006/main">
               <a:ext uri="{FF2B5EF4-FFF2-40B4-BE49-F238E27FC236}">
-                <a16:creationId xmlns:a16="http://schemas.microsoft.com/office/drawing/2014/main" id="{A8F3E2B7-78AD-4129-83EB-9C8E36E48862}"/>
+                <a16:creationId xmlns:a16="http://schemas.microsoft.com/office/drawing/2014/main" id="{CE3EB334-736E-4714-9AFD-03EC3B924227}"/>
               </a:ext>
             </a:extLst>
           </p:cNvPr>
@@ -6079,7 +6079,7 @@
           <p:cNvPr id="12" name="">
             <a:extLst xmlns:a="http://schemas.openxmlformats.org/drawingml/2006/main">
               <a:ext uri="{FF2B5EF4-FFF2-40B4-BE49-F238E27FC236}">
-                <a16:creationId xmlns:a16="http://schemas.microsoft.com/office/drawing/2014/main" id="{4D1C700A-817B-45A4-81AC-C9B185145924}"/>
+                <a16:creationId xmlns:a16="http://schemas.microsoft.com/office/drawing/2014/main" id="{2506F90F-883A-421B-B5A4-01F94DCE0B24}"/>
               </a:ext>
             </a:extLst>
           </p:cNvPr>
@@ -6141,7 +6141,7 @@
           <p:cNvPr id="13" name="">
             <a:extLst xmlns:a="http://schemas.openxmlformats.org/drawingml/2006/main">
               <a:ext uri="{FF2B5EF4-FFF2-40B4-BE49-F238E27FC236}">
-                <a16:creationId xmlns:a16="http://schemas.microsoft.com/office/drawing/2014/main" id="{649C0511-9125-4C4B-8F5C-70D5DE58C889}"/>
+                <a16:creationId xmlns:a16="http://schemas.microsoft.com/office/drawing/2014/main" id="{D695F79C-74D3-4B74-9C3F-3645809C204C}"/>
               </a:ext>
             </a:extLst>
           </p:cNvPr>
@@ -6203,7 +6203,7 @@
           <p:cNvPr id="14" name="">
             <a:extLst xmlns:a="http://schemas.openxmlformats.org/drawingml/2006/main">
               <a:ext uri="{FF2B5EF4-FFF2-40B4-BE49-F238E27FC236}">
-                <a16:creationId xmlns:a16="http://schemas.microsoft.com/office/drawing/2014/main" id="{3A233752-64AF-4385-9412-46A3AA9C6663}"/>
+                <a16:creationId xmlns:a16="http://schemas.microsoft.com/office/drawing/2014/main" id="{F300FD07-9345-4BFC-BF03-E9C1706107A2}"/>
               </a:ext>
             </a:extLst>
           </p:cNvPr>
@@ -6263,7 +6263,7 @@
     </p:spTree>
     <p:extLst>
       <p:ext uri="{BB962C8B-B14F-4D97-AF65-F5344CB8AC3E}">
-        <p14:creationId xmlns:p14="http://schemas.microsoft.com/office/powerpoint/2010/main" val="1693543844"/>
+        <p14:creationId xmlns:p14="http://schemas.microsoft.com/office/powerpoint/2010/main" val="824060146"/>
       </p:ext>
     </p:extLst>
   </p:cSld>
@@ -6294,7 +6294,7 @@
           <p:cNvPr id="10" name="">
             <a:extLst xmlns:a="http://schemas.openxmlformats.org/drawingml/2006/main">
               <a:ext uri="{FF2B5EF4-FFF2-40B4-BE49-F238E27FC236}">
-                <a16:creationId xmlns:a16="http://schemas.microsoft.com/office/drawing/2014/main" id="{5B69C98A-B00B-4C0D-9436-BCC064F7C206}"/>
+                <a16:creationId xmlns:a16="http://schemas.microsoft.com/office/drawing/2014/main" id="{E3D67C99-749C-40DE-B15D-99BD0443C1BC}"/>
               </a:ext>
             </a:extLst>
           </p:cNvPr>
@@ -6356,7 +6356,7 @@
           <p:cNvPr id="2" name="">
             <a:extLst xmlns:a="http://schemas.openxmlformats.org/drawingml/2006/main">
               <a:ext uri="{FF2B5EF4-FFF2-40B4-BE49-F238E27FC236}">
-                <a16:creationId xmlns:a16="http://schemas.microsoft.com/office/drawing/2014/main" id="{B19EBA5E-B3FF-4FC8-B4A2-017D98BF72FF}"/>
+                <a16:creationId xmlns:a16="http://schemas.microsoft.com/office/drawing/2014/main" id="{D1A59CC2-743C-4F7E-8F9A-909F7794C6E4}"/>
               </a:ext>
             </a:extLst>
           </p:cNvPr>
@@ -6418,7 +6418,7 @@
           <p:cNvPr id="3" name="big-statement">
             <a:extLst xmlns:a="http://schemas.openxmlformats.org/drawingml/2006/main">
               <a:ext uri="{FF2B5EF4-FFF2-40B4-BE49-F238E27FC236}">
-                <a16:creationId xmlns:a16="http://schemas.microsoft.com/office/drawing/2014/main" id="{A92309BA-2278-45EE-82E7-464E29D37FF7}"/>
+                <a16:creationId xmlns:a16="http://schemas.microsoft.com/office/drawing/2014/main" id="{26019BC0-6991-4A9F-BA7F-B0EA66D08F62}"/>
               </a:ext>
             </a:extLst>
           </p:cNvPr>
@@ -6480,7 +6480,7 @@
           <p:cNvPr id="4" name="bullet-mark-1">
             <a:extLst xmlns:a="http://schemas.openxmlformats.org/drawingml/2006/main">
               <a:ext uri="{FF2B5EF4-FFF2-40B4-BE49-F238E27FC236}">
-                <a16:creationId xmlns:a16="http://schemas.microsoft.com/office/drawing/2014/main" id="{69EFB515-3DEB-4679-B8EA-223A8BF725E6}"/>
+                <a16:creationId xmlns:a16="http://schemas.microsoft.com/office/drawing/2014/main" id="{C434CD36-6392-40BA-A27A-A9D010B8AAB0}"/>
               </a:ext>
             </a:extLst>
           </p:cNvPr>
@@ -6542,7 +6542,7 @@
           <p:cNvPr id="5" name="bullet-1">
             <a:extLst xmlns:a="http://schemas.openxmlformats.org/drawingml/2006/main">
               <a:ext uri="{FF2B5EF4-FFF2-40B4-BE49-F238E27FC236}">
-                <a16:creationId xmlns:a16="http://schemas.microsoft.com/office/drawing/2014/main" id="{D5BCF8EB-E867-466C-8A4B-38EA99EC232B}"/>
+                <a16:creationId xmlns:a16="http://schemas.microsoft.com/office/drawing/2014/main" id="{C94BD018-3F60-4526-B183-FDE40669F9AD}"/>
               </a:ext>
             </a:extLst>
           </p:cNvPr>
@@ -6604,7 +6604,7 @@
           <p:cNvPr id="6" name="bullet-mark-2">
             <a:extLst xmlns:a="http://schemas.openxmlformats.org/drawingml/2006/main">
               <a:ext uri="{FF2B5EF4-FFF2-40B4-BE49-F238E27FC236}">
-                <a16:creationId xmlns:a16="http://schemas.microsoft.com/office/drawing/2014/main" id="{A77389AC-9A00-4623-8AA2-9932A70EF22F}"/>
+                <a16:creationId xmlns:a16="http://schemas.microsoft.com/office/drawing/2014/main" id="{F85D5EA0-81C8-40DE-B0EE-28C08F05FFE4}"/>
               </a:ext>
             </a:extLst>
           </p:cNvPr>
@@ -6666,7 +6666,7 @@
           <p:cNvPr id="7" name="bullet-2">
             <a:extLst xmlns:a="http://schemas.openxmlformats.org/drawingml/2006/main">
               <a:ext uri="{FF2B5EF4-FFF2-40B4-BE49-F238E27FC236}">
-                <a16:creationId xmlns:a16="http://schemas.microsoft.com/office/drawing/2014/main" id="{FBEFEB9C-40B1-422A-9FB3-477841288726}"/>
+                <a16:creationId xmlns:a16="http://schemas.microsoft.com/office/drawing/2014/main" id="{31E7251A-AECD-4239-AFCA-B6563B458138}"/>
               </a:ext>
             </a:extLst>
           </p:cNvPr>
@@ -6728,7 +6728,7 @@
           <p:cNvPr id="8" name="bullet-mark-3">
             <a:extLst xmlns:a="http://schemas.openxmlformats.org/drawingml/2006/main">
               <a:ext uri="{FF2B5EF4-FFF2-40B4-BE49-F238E27FC236}">
-                <a16:creationId xmlns:a16="http://schemas.microsoft.com/office/drawing/2014/main" id="{05C846C0-4AC4-429A-9418-75CD67857641}"/>
+                <a16:creationId xmlns:a16="http://schemas.microsoft.com/office/drawing/2014/main" id="{AD0D134A-63CF-407A-90CD-A8DD1D4D9D56}"/>
               </a:ext>
             </a:extLst>
           </p:cNvPr>
@@ -6790,7 +6790,7 @@
           <p:cNvPr id="9" name="bullet-3">
             <a:extLst xmlns:a="http://schemas.openxmlformats.org/drawingml/2006/main">
               <a:ext uri="{FF2B5EF4-FFF2-40B4-BE49-F238E27FC236}">
-                <a16:creationId xmlns:a16="http://schemas.microsoft.com/office/drawing/2014/main" id="{FC39827F-188E-42CD-9925-06E84E39E2BD}"/>
+                <a16:creationId xmlns:a16="http://schemas.microsoft.com/office/drawing/2014/main" id="{6D08F29D-678E-4480-8A79-9BA3040AAD38}"/>
               </a:ext>
             </a:extLst>
           </p:cNvPr>
@@ -6850,7 +6850,7 @@
     </p:spTree>
     <p:extLst>
       <p:ext uri="{BB962C8B-B14F-4D97-AF65-F5344CB8AC3E}">
-        <p14:creationId xmlns:p14="http://schemas.microsoft.com/office/powerpoint/2010/main" val="1348808423"/>
+        <p14:creationId xmlns:p14="http://schemas.microsoft.com/office/powerpoint/2010/main" val="94088135"/>
       </p:ext>
     </p:extLst>
   </p:cSld>
@@ -6881,7 +6881,7 @@
           <p:cNvPr id="8" name="chapter-label">
             <a:extLst xmlns:a="http://schemas.openxmlformats.org/drawingml/2006/main">
               <a:ext uri="{FF2B5EF4-FFF2-40B4-BE49-F238E27FC236}">
-                <a16:creationId xmlns:a16="http://schemas.microsoft.com/office/drawing/2014/main" id="{F3C8DC3E-71E1-4D6D-B1D4-D66FB7F2F3B6}"/>
+                <a16:creationId xmlns:a16="http://schemas.microsoft.com/office/drawing/2014/main" id="{DA2D60C3-C478-4D73-8722-2F80ABFFA634}"/>
               </a:ext>
             </a:extLst>
           </p:cNvPr>
@@ -6943,7 +6943,7 @@
           <p:cNvPr id="2" name="slide-title">
             <a:extLst xmlns:a="http://schemas.openxmlformats.org/drawingml/2006/main">
               <a:ext uri="{FF2B5EF4-FFF2-40B4-BE49-F238E27FC236}">
-                <a16:creationId xmlns:a16="http://schemas.microsoft.com/office/drawing/2014/main" id="{0A0ED004-4948-4DF6-9C6F-2FD0B354D60C}"/>
+                <a16:creationId xmlns:a16="http://schemas.microsoft.com/office/drawing/2014/main" id="{FE567DA6-5898-42CF-9CD1-4E2A9F0FC35D}"/>
               </a:ext>
             </a:extLst>
           </p:cNvPr>
@@ -7005,7 +7005,7 @@
           <p:cNvPr id="3" name="footer-rule">
             <a:extLst xmlns:a="http://schemas.openxmlformats.org/drawingml/2006/main">
               <a:ext uri="{FF2B5EF4-FFF2-40B4-BE49-F238E27FC236}">
-                <a16:creationId xmlns:a16="http://schemas.microsoft.com/office/drawing/2014/main" id="{4DD7DA99-37D1-47BF-ADDE-308CB78A2408}"/>
+                <a16:creationId xmlns:a16="http://schemas.microsoft.com/office/drawing/2014/main" id="{F2D8F672-6C71-4967-A3FC-508D1F527BC9}"/>
               </a:ext>
             </a:extLst>
           </p:cNvPr>
@@ -7036,7 +7036,7 @@
           <p:cNvPr id="4" name="footer-book">
             <a:extLst xmlns:a="http://schemas.openxmlformats.org/drawingml/2006/main">
               <a:ext uri="{FF2B5EF4-FFF2-40B4-BE49-F238E27FC236}">
-                <a16:creationId xmlns:a16="http://schemas.microsoft.com/office/drawing/2014/main" id="{A018424F-E6AE-46EF-9C57-4BD8774D207C}"/>
+                <a16:creationId xmlns:a16="http://schemas.microsoft.com/office/drawing/2014/main" id="{D9626494-8F03-43E4-9A38-D3712F7C7BCD}"/>
               </a:ext>
             </a:extLst>
           </p:cNvPr>
@@ -7098,7 +7098,7 @@
           <p:cNvPr id="5" name="footer-number">
             <a:extLst xmlns:a="http://schemas.openxmlformats.org/drawingml/2006/main">
               <a:ext uri="{FF2B5EF4-FFF2-40B4-BE49-F238E27FC236}">
-                <a16:creationId xmlns:a16="http://schemas.microsoft.com/office/drawing/2014/main" id="{169456CD-ECF6-4D6C-9BDA-FA5C91DBB12A}"/>
+                <a16:creationId xmlns:a16="http://schemas.microsoft.com/office/drawing/2014/main" id="{B80E1DBD-4BF0-422D-83B9-3D523F4DEA4A}"/>
               </a:ext>
             </a:extLst>
           </p:cNvPr>
@@ -7164,7 +7164,7 @@
           <p:nvPr/>
         </p:nvPicPr>
         <p:blipFill>
-          <a:blip xmlns:r="http://schemas.openxmlformats.org/officeDocument/2006/relationships" xmlns:a="http://schemas.openxmlformats.org/drawingml/2006/main" r:embed="R12a2b73194fe415d"/>
+          <a:blip xmlns:r="http://schemas.openxmlformats.org/officeDocument/2006/relationships" xmlns:a="http://schemas.openxmlformats.org/drawingml/2006/main" r:embed="R041b4e20f19f44b1"/>
           <a:stretch xmlns:a="http://schemas.openxmlformats.org/drawingml/2006/main"/>
         </p:blipFill>
         <p:spPr>
@@ -7182,7 +7182,7 @@
           <p:cNvPr id="7" name="">
             <a:extLst xmlns:a="http://schemas.openxmlformats.org/drawingml/2006/main">
               <a:ext uri="{FF2B5EF4-FFF2-40B4-BE49-F238E27FC236}">
-                <a16:creationId xmlns:a16="http://schemas.microsoft.com/office/drawing/2014/main" id="{C9C9FB24-9D1E-451A-906F-B2B3A87E06CC}"/>
+                <a16:creationId xmlns:a16="http://schemas.microsoft.com/office/drawing/2014/main" id="{ADE222C9-0A4A-4383-A048-FDCF7F8BBEAF}"/>
               </a:ext>
             </a:extLst>
           </p:cNvPr>
@@ -7242,7 +7242,7 @@
     </p:spTree>
     <p:extLst>
       <p:ext uri="{BB962C8B-B14F-4D97-AF65-F5344CB8AC3E}">
-        <p14:creationId xmlns:p14="http://schemas.microsoft.com/office/powerpoint/2010/main" val="979311901"/>
+        <p14:creationId xmlns:p14="http://schemas.microsoft.com/office/powerpoint/2010/main" val="311457612"/>
       </p:ext>
     </p:extLst>
   </p:cSld>
@@ -7273,7 +7273,7 @@
           <p:cNvPr id="19" name="chapter-label">
             <a:extLst xmlns:a="http://schemas.openxmlformats.org/drawingml/2006/main">
               <a:ext uri="{FF2B5EF4-FFF2-40B4-BE49-F238E27FC236}">
-                <a16:creationId xmlns:a16="http://schemas.microsoft.com/office/drawing/2014/main" id="{FC04EC12-6343-4452-B028-42E35FBC31EE}"/>
+                <a16:creationId xmlns:a16="http://schemas.microsoft.com/office/drawing/2014/main" id="{2379152F-3D6F-4087-81E1-AD426747FA24}"/>
               </a:ext>
             </a:extLst>
           </p:cNvPr>
@@ -7335,7 +7335,7 @@
           <p:cNvPr id="2" name="slide-title">
             <a:extLst xmlns:a="http://schemas.openxmlformats.org/drawingml/2006/main">
               <a:ext uri="{FF2B5EF4-FFF2-40B4-BE49-F238E27FC236}">
-                <a16:creationId xmlns:a16="http://schemas.microsoft.com/office/drawing/2014/main" id="{0C9ACD40-D598-482F-8C85-FD7DA9434AEC}"/>
+                <a16:creationId xmlns:a16="http://schemas.microsoft.com/office/drawing/2014/main" id="{3418CA7E-0BE1-46C9-9492-1CB4FCB7C5A7}"/>
               </a:ext>
             </a:extLst>
           </p:cNvPr>
@@ -7397,7 +7397,7 @@
           <p:cNvPr id="3" name="footer-rule">
             <a:extLst xmlns:a="http://schemas.openxmlformats.org/drawingml/2006/main">
               <a:ext uri="{FF2B5EF4-FFF2-40B4-BE49-F238E27FC236}">
-                <a16:creationId xmlns:a16="http://schemas.microsoft.com/office/drawing/2014/main" id="{498C8AEE-5798-4421-B729-547A3D8CE2C0}"/>
+                <a16:creationId xmlns:a16="http://schemas.microsoft.com/office/drawing/2014/main" id="{57266E97-C004-4104-82B4-F9CF8B6B7AE8}"/>
               </a:ext>
             </a:extLst>
           </p:cNvPr>
@@ -7428,7 +7428,7 @@
           <p:cNvPr id="4" name="footer-book">
             <a:extLst xmlns:a="http://schemas.openxmlformats.org/drawingml/2006/main">
               <a:ext uri="{FF2B5EF4-FFF2-40B4-BE49-F238E27FC236}">
-                <a16:creationId xmlns:a16="http://schemas.microsoft.com/office/drawing/2014/main" id="{1CB2C327-CC8A-4C7B-8740-7269BE757557}"/>
+                <a16:creationId xmlns:a16="http://schemas.microsoft.com/office/drawing/2014/main" id="{00698D2C-7D65-405E-AA82-A42AE85D95E0}"/>
               </a:ext>
             </a:extLst>
           </p:cNvPr>
@@ -7490,7 +7490,7 @@
           <p:cNvPr id="5" name="footer-number">
             <a:extLst xmlns:a="http://schemas.openxmlformats.org/drawingml/2006/main">
               <a:ext uri="{FF2B5EF4-FFF2-40B4-BE49-F238E27FC236}">
-                <a16:creationId xmlns:a16="http://schemas.microsoft.com/office/drawing/2014/main" id="{660530EB-5F67-46A5-91D9-39A4D7F70E0D}"/>
+                <a16:creationId xmlns:a16="http://schemas.microsoft.com/office/drawing/2014/main" id="{AC862414-5204-49D2-BCC9-08DB75F3C902}"/>
               </a:ext>
             </a:extLst>
           </p:cNvPr>
@@ -7552,7 +7552,7 @@
           <p:cNvPr id="6" name="panel-1">
             <a:extLst xmlns:a="http://schemas.openxmlformats.org/drawingml/2006/main">
               <a:ext uri="{FF2B5EF4-FFF2-40B4-BE49-F238E27FC236}">
-                <a16:creationId xmlns:a16="http://schemas.microsoft.com/office/drawing/2014/main" id="{A3478FC8-62E3-4DE0-877E-70A4E6505DD2}"/>
+                <a16:creationId xmlns:a16="http://schemas.microsoft.com/office/drawing/2014/main" id="{6FF03535-4491-43D5-9E9A-49712BED8E62}"/>
               </a:ext>
             </a:extLst>
           </p:cNvPr>
@@ -7585,7 +7585,7 @@
           <p:cNvPr id="7" name="">
             <a:extLst xmlns:a="http://schemas.openxmlformats.org/drawingml/2006/main">
               <a:ext uri="{FF2B5EF4-FFF2-40B4-BE49-F238E27FC236}">
-                <a16:creationId xmlns:a16="http://schemas.microsoft.com/office/drawing/2014/main" id="{F8038B91-0041-4FB0-8F96-FC659A25A8F2}"/>
+                <a16:creationId xmlns:a16="http://schemas.microsoft.com/office/drawing/2014/main" id="{4C335075-4A83-402A-A7AD-C2B1F44421ED}"/>
               </a:ext>
             </a:extLst>
           </p:cNvPr>
@@ -7647,7 +7647,7 @@
           <p:cNvPr id="8" name="">
             <a:extLst xmlns:a="http://schemas.openxmlformats.org/drawingml/2006/main">
               <a:ext uri="{FF2B5EF4-FFF2-40B4-BE49-F238E27FC236}">
-                <a16:creationId xmlns:a16="http://schemas.microsoft.com/office/drawing/2014/main" id="{EDDF1EBD-0DA7-42D3-A361-E9D0E3EED068}"/>
+                <a16:creationId xmlns:a16="http://schemas.microsoft.com/office/drawing/2014/main" id="{2C9F2E69-BE6F-40F5-9BE1-1AF30DFD6FBB}"/>
               </a:ext>
             </a:extLst>
           </p:cNvPr>
@@ -7709,7 +7709,7 @@
           <p:cNvPr id="9" name="">
             <a:extLst xmlns:a="http://schemas.openxmlformats.org/drawingml/2006/main">
               <a:ext uri="{FF2B5EF4-FFF2-40B4-BE49-F238E27FC236}">
-                <a16:creationId xmlns:a16="http://schemas.microsoft.com/office/drawing/2014/main" id="{8DEC17BE-D86D-4089-8F49-CD52F71CB70F}"/>
+                <a16:creationId xmlns:a16="http://schemas.microsoft.com/office/drawing/2014/main" id="{14288790-C6BB-4213-B2C5-200439C745A4}"/>
               </a:ext>
             </a:extLst>
           </p:cNvPr>
@@ -7771,7 +7771,7 @@
           <p:cNvPr id="10" name="panel-2">
             <a:extLst xmlns:a="http://schemas.openxmlformats.org/drawingml/2006/main">
               <a:ext uri="{FF2B5EF4-FFF2-40B4-BE49-F238E27FC236}">
-                <a16:creationId xmlns:a16="http://schemas.microsoft.com/office/drawing/2014/main" id="{A9437BD4-377B-48EB-91BB-119052A2F675}"/>
+                <a16:creationId xmlns:a16="http://schemas.microsoft.com/office/drawing/2014/main" id="{51C021D3-B568-4FC3-87F5-B0A6DAFACB12}"/>
               </a:ext>
             </a:extLst>
           </p:cNvPr>
@@ -7804,7 +7804,7 @@
           <p:cNvPr id="11" name="">
             <a:extLst xmlns:a="http://schemas.openxmlformats.org/drawingml/2006/main">
               <a:ext uri="{FF2B5EF4-FFF2-40B4-BE49-F238E27FC236}">
-                <a16:creationId xmlns:a16="http://schemas.microsoft.com/office/drawing/2014/main" id="{0BC357FC-46CB-4F55-8C36-A2660239D8BA}"/>
+                <a16:creationId xmlns:a16="http://schemas.microsoft.com/office/drawing/2014/main" id="{B0BDEBD1-24DE-40ED-8C9C-F835D3F847E6}"/>
               </a:ext>
             </a:extLst>
           </p:cNvPr>
@@ -7866,7 +7866,7 @@
           <p:cNvPr id="12" name="">
             <a:extLst xmlns:a="http://schemas.openxmlformats.org/drawingml/2006/main">
               <a:ext uri="{FF2B5EF4-FFF2-40B4-BE49-F238E27FC236}">
-                <a16:creationId xmlns:a16="http://schemas.microsoft.com/office/drawing/2014/main" id="{5030A390-2E35-40FB-850E-C26DDDD06284}"/>
+                <a16:creationId xmlns:a16="http://schemas.microsoft.com/office/drawing/2014/main" id="{E4D92958-2EDB-466B-9D7D-AB6A295D8620}"/>
               </a:ext>
             </a:extLst>
           </p:cNvPr>
@@ -7928,7 +7928,7 @@
           <p:cNvPr id="13" name="">
             <a:extLst xmlns:a="http://schemas.openxmlformats.org/drawingml/2006/main">
               <a:ext uri="{FF2B5EF4-FFF2-40B4-BE49-F238E27FC236}">
-                <a16:creationId xmlns:a16="http://schemas.microsoft.com/office/drawing/2014/main" id="{029EB711-CC73-4C2A-95D2-0524300F1B91}"/>
+                <a16:creationId xmlns:a16="http://schemas.microsoft.com/office/drawing/2014/main" id="{7D8FF166-6564-4FBF-89EA-EC628F0E184C}"/>
               </a:ext>
             </a:extLst>
           </p:cNvPr>
@@ -7990,7 +7990,7 @@
           <p:cNvPr id="14" name="panel-3">
             <a:extLst xmlns:a="http://schemas.openxmlformats.org/drawingml/2006/main">
               <a:ext uri="{FF2B5EF4-FFF2-40B4-BE49-F238E27FC236}">
-                <a16:creationId xmlns:a16="http://schemas.microsoft.com/office/drawing/2014/main" id="{951E4220-DDB9-4665-9C90-D758390A5A67}"/>
+                <a16:creationId xmlns:a16="http://schemas.microsoft.com/office/drawing/2014/main" id="{5B27C88D-4E37-40A5-AFCA-66A8EB7D06A5}"/>
               </a:ext>
             </a:extLst>
           </p:cNvPr>
@@ -8023,7 +8023,7 @@
           <p:cNvPr id="15" name="">
             <a:extLst xmlns:a="http://schemas.openxmlformats.org/drawingml/2006/main">
               <a:ext uri="{FF2B5EF4-FFF2-40B4-BE49-F238E27FC236}">
-                <a16:creationId xmlns:a16="http://schemas.microsoft.com/office/drawing/2014/main" id="{7A22E00B-F1D0-4020-944D-F84A6401C9C3}"/>
+                <a16:creationId xmlns:a16="http://schemas.microsoft.com/office/drawing/2014/main" id="{52CDCF27-EA44-47CE-8C53-458FAE961F25}"/>
               </a:ext>
             </a:extLst>
           </p:cNvPr>
@@ -8085,7 +8085,7 @@
           <p:cNvPr id="16" name="">
             <a:extLst xmlns:a="http://schemas.openxmlformats.org/drawingml/2006/main">
               <a:ext uri="{FF2B5EF4-FFF2-40B4-BE49-F238E27FC236}">
-                <a16:creationId xmlns:a16="http://schemas.microsoft.com/office/drawing/2014/main" id="{1008E22E-865B-448A-9856-B7A63E89EFB8}"/>
+                <a16:creationId xmlns:a16="http://schemas.microsoft.com/office/drawing/2014/main" id="{4947E84F-AF30-4053-820E-F15EC35582B9}"/>
               </a:ext>
             </a:extLst>
           </p:cNvPr>
@@ -8147,7 +8147,7 @@
           <p:cNvPr id="17" name="">
             <a:extLst xmlns:a="http://schemas.openxmlformats.org/drawingml/2006/main">
               <a:ext uri="{FF2B5EF4-FFF2-40B4-BE49-F238E27FC236}">
-                <a16:creationId xmlns:a16="http://schemas.microsoft.com/office/drawing/2014/main" id="{D28B2F5D-772F-4946-B342-92269667B447}"/>
+                <a16:creationId xmlns:a16="http://schemas.microsoft.com/office/drawing/2014/main" id="{2C60BA1C-CD33-4389-8390-841642E9D2D3}"/>
               </a:ext>
             </a:extLst>
           </p:cNvPr>
@@ -8209,7 +8209,7 @@
           <p:cNvPr id="18" name="">
             <a:extLst xmlns:a="http://schemas.openxmlformats.org/drawingml/2006/main">
               <a:ext uri="{FF2B5EF4-FFF2-40B4-BE49-F238E27FC236}">
-                <a16:creationId xmlns:a16="http://schemas.microsoft.com/office/drawing/2014/main" id="{62BEEF26-5D26-43EF-B9B5-298636BEE1E6}"/>
+                <a16:creationId xmlns:a16="http://schemas.microsoft.com/office/drawing/2014/main" id="{3C8AB65A-0AE8-4514-9559-DE631D652A7E}"/>
               </a:ext>
             </a:extLst>
           </p:cNvPr>
@@ -8269,7 +8269,7 @@
     </p:spTree>
     <p:extLst>
       <p:ext uri="{BB962C8B-B14F-4D97-AF65-F5344CB8AC3E}">
-        <p14:creationId xmlns:p14="http://schemas.microsoft.com/office/powerpoint/2010/main" val="1720488930"/>
+        <p14:creationId xmlns:p14="http://schemas.microsoft.com/office/powerpoint/2010/main" val="1132712769"/>
       </p:ext>
     </p:extLst>
   </p:cSld>
@@ -8300,7 +8300,7 @@
           <p:cNvPr id="17" name="chapter-label">
             <a:extLst xmlns:a="http://schemas.openxmlformats.org/drawingml/2006/main">
               <a:ext uri="{FF2B5EF4-FFF2-40B4-BE49-F238E27FC236}">
-                <a16:creationId xmlns:a16="http://schemas.microsoft.com/office/drawing/2014/main" id="{63DEB131-5419-44FF-B4CF-1F435B842BAF}"/>
+                <a16:creationId xmlns:a16="http://schemas.microsoft.com/office/drawing/2014/main" id="{FA720163-013B-4FA2-82EE-944A3CEFFD00}"/>
               </a:ext>
             </a:extLst>
           </p:cNvPr>
@@ -8362,7 +8362,7 @@
           <p:cNvPr id="2" name="slide-title">
             <a:extLst xmlns:a="http://schemas.openxmlformats.org/drawingml/2006/main">
               <a:ext uri="{FF2B5EF4-FFF2-40B4-BE49-F238E27FC236}">
-                <a16:creationId xmlns:a16="http://schemas.microsoft.com/office/drawing/2014/main" id="{6A123AD2-F1F2-4F6B-87FF-44BDF5AFAAA3}"/>
+                <a16:creationId xmlns:a16="http://schemas.microsoft.com/office/drawing/2014/main" id="{8C562079-B815-45C1-8499-7D3AC37AFF87}"/>
               </a:ext>
             </a:extLst>
           </p:cNvPr>
@@ -8424,7 +8424,7 @@
           <p:cNvPr id="3" name="footer-rule">
             <a:extLst xmlns:a="http://schemas.openxmlformats.org/drawingml/2006/main">
               <a:ext uri="{FF2B5EF4-FFF2-40B4-BE49-F238E27FC236}">
-                <a16:creationId xmlns:a16="http://schemas.microsoft.com/office/drawing/2014/main" id="{DE39101A-33F8-4EFD-9F74-5C597CDFE682}"/>
+                <a16:creationId xmlns:a16="http://schemas.microsoft.com/office/drawing/2014/main" id="{F701776E-8567-4D92-BDC0-F9422F8C776F}"/>
               </a:ext>
             </a:extLst>
           </p:cNvPr>
@@ -8455,7 +8455,7 @@
           <p:cNvPr id="4" name="footer-book">
             <a:extLst xmlns:a="http://schemas.openxmlformats.org/drawingml/2006/main">
               <a:ext uri="{FF2B5EF4-FFF2-40B4-BE49-F238E27FC236}">
-                <a16:creationId xmlns:a16="http://schemas.microsoft.com/office/drawing/2014/main" id="{3BA12EDF-81B3-4337-BF4E-2DFA75403764}"/>
+                <a16:creationId xmlns:a16="http://schemas.microsoft.com/office/drawing/2014/main" id="{1DB7107D-94AD-448E-8132-5B61A7C69450}"/>
               </a:ext>
             </a:extLst>
           </p:cNvPr>
@@ -8517,7 +8517,7 @@
           <p:cNvPr id="5" name="footer-number">
             <a:extLst xmlns:a="http://schemas.openxmlformats.org/drawingml/2006/main">
               <a:ext uri="{FF2B5EF4-FFF2-40B4-BE49-F238E27FC236}">
-                <a16:creationId xmlns:a16="http://schemas.microsoft.com/office/drawing/2014/main" id="{FC4A2DE2-6A96-4E74-A210-6795BE2DDD3A}"/>
+                <a16:creationId xmlns:a16="http://schemas.microsoft.com/office/drawing/2014/main" id="{0FEA6B2E-4811-4C24-8C3F-578C69806F1E}"/>
               </a:ext>
             </a:extLst>
           </p:cNvPr>
@@ -8579,7 +8579,7 @@
           <p:cNvPr id="6" name="bullet-mark-1">
             <a:extLst xmlns:a="http://schemas.openxmlformats.org/drawingml/2006/main">
               <a:ext uri="{FF2B5EF4-FFF2-40B4-BE49-F238E27FC236}">
-                <a16:creationId xmlns:a16="http://schemas.microsoft.com/office/drawing/2014/main" id="{3CC496EB-E0E3-420C-8209-CBEFFE4FE27F}"/>
+                <a16:creationId xmlns:a16="http://schemas.microsoft.com/office/drawing/2014/main" id="{0E9BC683-D8A2-489F-AAF3-2E29167C9F10}"/>
               </a:ext>
             </a:extLst>
           </p:cNvPr>
@@ -8641,7 +8641,7 @@
           <p:cNvPr id="7" name="bullet-1">
             <a:extLst xmlns:a="http://schemas.openxmlformats.org/drawingml/2006/main">
               <a:ext uri="{FF2B5EF4-FFF2-40B4-BE49-F238E27FC236}">
-                <a16:creationId xmlns:a16="http://schemas.microsoft.com/office/drawing/2014/main" id="{46546681-54CA-4A22-8B63-D1F079CE6F18}"/>
+                <a16:creationId xmlns:a16="http://schemas.microsoft.com/office/drawing/2014/main" id="{6E0F5FBC-7CC3-4316-B855-9D77440BC2D4}"/>
               </a:ext>
             </a:extLst>
           </p:cNvPr>
@@ -8703,7 +8703,7 @@
           <p:cNvPr id="8" name="bullet-mark-2">
             <a:extLst xmlns:a="http://schemas.openxmlformats.org/drawingml/2006/main">
               <a:ext uri="{FF2B5EF4-FFF2-40B4-BE49-F238E27FC236}">
-                <a16:creationId xmlns:a16="http://schemas.microsoft.com/office/drawing/2014/main" id="{0E423D2C-71B7-400A-9B9B-EEEAEB8B4D32}"/>
+                <a16:creationId xmlns:a16="http://schemas.microsoft.com/office/drawing/2014/main" id="{98F453EE-959D-4130-9AA3-CEA2858124CD}"/>
               </a:ext>
             </a:extLst>
           </p:cNvPr>
@@ -8765,7 +8765,7 @@
           <p:cNvPr id="9" name="bullet-2">
             <a:extLst xmlns:a="http://schemas.openxmlformats.org/drawingml/2006/main">
               <a:ext uri="{FF2B5EF4-FFF2-40B4-BE49-F238E27FC236}">
-                <a16:creationId xmlns:a16="http://schemas.microsoft.com/office/drawing/2014/main" id="{42B02614-97AB-4444-ABCA-CE94BEEAD067}"/>
+                <a16:creationId xmlns:a16="http://schemas.microsoft.com/office/drawing/2014/main" id="{0C4C4439-B4DA-4BC3-9A9A-4D10FA5B0D4C}"/>
               </a:ext>
             </a:extLst>
           </p:cNvPr>
@@ -8827,7 +8827,7 @@
           <p:cNvPr id="10" name="bullet-mark-3">
             <a:extLst xmlns:a="http://schemas.openxmlformats.org/drawingml/2006/main">
               <a:ext uri="{FF2B5EF4-FFF2-40B4-BE49-F238E27FC236}">
-                <a16:creationId xmlns:a16="http://schemas.microsoft.com/office/drawing/2014/main" id="{A1D0702A-5C3A-4230-BAAB-89002357B185}"/>
+                <a16:creationId xmlns:a16="http://schemas.microsoft.com/office/drawing/2014/main" id="{5E49BCE8-36CC-4A77-A6AC-0602AADDAE99}"/>
               </a:ext>
             </a:extLst>
           </p:cNvPr>
@@ -8889,7 +8889,7 @@
           <p:cNvPr id="11" name="bullet-3">
             <a:extLst xmlns:a="http://schemas.openxmlformats.org/drawingml/2006/main">
               <a:ext uri="{FF2B5EF4-FFF2-40B4-BE49-F238E27FC236}">
-                <a16:creationId xmlns:a16="http://schemas.microsoft.com/office/drawing/2014/main" id="{6F2E58F2-1B8E-4E06-8487-753CA35C2BC9}"/>
+                <a16:creationId xmlns:a16="http://schemas.microsoft.com/office/drawing/2014/main" id="{2B3F2784-C139-47C3-A617-17DCDC422D58}"/>
               </a:ext>
             </a:extLst>
           </p:cNvPr>
@@ -8951,7 +8951,7 @@
           <p:cNvPr id="12" name="bullet-mark-4">
             <a:extLst xmlns:a="http://schemas.openxmlformats.org/drawingml/2006/main">
               <a:ext uri="{FF2B5EF4-FFF2-40B4-BE49-F238E27FC236}">
-                <a16:creationId xmlns:a16="http://schemas.microsoft.com/office/drawing/2014/main" id="{E4C0C78B-67C6-483A-8CD3-7B786181761B}"/>
+                <a16:creationId xmlns:a16="http://schemas.microsoft.com/office/drawing/2014/main" id="{F3E8256B-F250-47F5-8104-5F39FC9246B2}"/>
               </a:ext>
             </a:extLst>
           </p:cNvPr>
@@ -9013,7 +9013,7 @@
           <p:cNvPr id="13" name="bullet-4">
             <a:extLst xmlns:a="http://schemas.openxmlformats.org/drawingml/2006/main">
               <a:ext uri="{FF2B5EF4-FFF2-40B4-BE49-F238E27FC236}">
-                <a16:creationId xmlns:a16="http://schemas.microsoft.com/office/drawing/2014/main" id="{6A2A6193-7D4C-4F09-9650-AB65C0D14392}"/>
+                <a16:creationId xmlns:a16="http://schemas.microsoft.com/office/drawing/2014/main" id="{712BF3C5-8B77-423C-89B8-7BEE8CD5091A}"/>
               </a:ext>
             </a:extLst>
           </p:cNvPr>
@@ -9075,7 +9075,7 @@
           <p:cNvPr id="14" name="bullet-mark-5">
             <a:extLst xmlns:a="http://schemas.openxmlformats.org/drawingml/2006/main">
               <a:ext uri="{FF2B5EF4-FFF2-40B4-BE49-F238E27FC236}">
-                <a16:creationId xmlns:a16="http://schemas.microsoft.com/office/drawing/2014/main" id="{14F2ECD4-C65C-4E9D-8E3E-E370D7371AA9}"/>
+                <a16:creationId xmlns:a16="http://schemas.microsoft.com/office/drawing/2014/main" id="{3C45DF3D-C120-40A4-9699-4B99DB56470E}"/>
               </a:ext>
             </a:extLst>
           </p:cNvPr>
@@ -9137,7 +9137,7 @@
           <p:cNvPr id="15" name="bullet-5">
             <a:extLst xmlns:a="http://schemas.openxmlformats.org/drawingml/2006/main">
               <a:ext uri="{FF2B5EF4-FFF2-40B4-BE49-F238E27FC236}">
-                <a16:creationId xmlns:a16="http://schemas.microsoft.com/office/drawing/2014/main" id="{04CBCB42-ABC3-4EB6-934D-6DEC2E88E472}"/>
+                <a16:creationId xmlns:a16="http://schemas.microsoft.com/office/drawing/2014/main" id="{757FB077-8147-4D85-A282-DCE701ADBD81}"/>
               </a:ext>
             </a:extLst>
           </p:cNvPr>
@@ -9199,7 +9199,7 @@
           <p:cNvPr id="16" name="">
             <a:extLst xmlns:a="http://schemas.openxmlformats.org/drawingml/2006/main">
               <a:ext uri="{FF2B5EF4-FFF2-40B4-BE49-F238E27FC236}">
-                <a16:creationId xmlns:a16="http://schemas.microsoft.com/office/drawing/2014/main" id="{EBABB678-17BC-4BA4-94B8-7A0AAFEB5496}"/>
+                <a16:creationId xmlns:a16="http://schemas.microsoft.com/office/drawing/2014/main" id="{928B9B95-2649-4220-BCEA-93BFC81DA326}"/>
               </a:ext>
             </a:extLst>
           </p:cNvPr>
@@ -9259,7 +9259,7 @@
     </p:spTree>
     <p:extLst>
       <p:ext uri="{BB962C8B-B14F-4D97-AF65-F5344CB8AC3E}">
-        <p14:creationId xmlns:p14="http://schemas.microsoft.com/office/powerpoint/2010/main" val="686576133"/>
+        <p14:creationId xmlns:p14="http://schemas.microsoft.com/office/powerpoint/2010/main" val="1568636076"/>
       </p:ext>
     </p:extLst>
   </p:cSld>
@@ -9290,7 +9290,7 @@
           <p:cNvPr id="15" name="chapter-label">
             <a:extLst xmlns:a="http://schemas.openxmlformats.org/drawingml/2006/main">
               <a:ext uri="{FF2B5EF4-FFF2-40B4-BE49-F238E27FC236}">
-                <a16:creationId xmlns:a16="http://schemas.microsoft.com/office/drawing/2014/main" id="{E26736C5-5749-40F8-BDE6-DE5E1705D8E7}"/>
+                <a16:creationId xmlns:a16="http://schemas.microsoft.com/office/drawing/2014/main" id="{8BF073EF-4B72-457C-B13B-57EEEC610A5E}"/>
               </a:ext>
             </a:extLst>
           </p:cNvPr>
@@ -9352,7 +9352,7 @@
           <p:cNvPr id="2" name="slide-title">
             <a:extLst xmlns:a="http://schemas.openxmlformats.org/drawingml/2006/main">
               <a:ext uri="{FF2B5EF4-FFF2-40B4-BE49-F238E27FC236}">
-                <a16:creationId xmlns:a16="http://schemas.microsoft.com/office/drawing/2014/main" id="{886574D6-60F3-4CE0-B4CB-87234987E479}"/>
+                <a16:creationId xmlns:a16="http://schemas.microsoft.com/office/drawing/2014/main" id="{F13C73ED-2631-4783-9D99-27420C1C3546}"/>
               </a:ext>
             </a:extLst>
           </p:cNvPr>
@@ -9414,7 +9414,7 @@
           <p:cNvPr id="3" name="footer-rule">
             <a:extLst xmlns:a="http://schemas.openxmlformats.org/drawingml/2006/main">
               <a:ext uri="{FF2B5EF4-FFF2-40B4-BE49-F238E27FC236}">
-                <a16:creationId xmlns:a16="http://schemas.microsoft.com/office/drawing/2014/main" id="{E38D64AC-DAFA-4AA8-95D9-6F7B25DB5C4D}"/>
+                <a16:creationId xmlns:a16="http://schemas.microsoft.com/office/drawing/2014/main" id="{3D265A18-491E-4F9C-A62B-E2EE454D5F25}"/>
               </a:ext>
             </a:extLst>
           </p:cNvPr>
@@ -9445,7 +9445,7 @@
           <p:cNvPr id="4" name="footer-book">
             <a:extLst xmlns:a="http://schemas.openxmlformats.org/drawingml/2006/main">
               <a:ext uri="{FF2B5EF4-FFF2-40B4-BE49-F238E27FC236}">
-                <a16:creationId xmlns:a16="http://schemas.microsoft.com/office/drawing/2014/main" id="{928DBD2C-69C8-4145-9D4A-40A4D4CBA483}"/>
+                <a16:creationId xmlns:a16="http://schemas.microsoft.com/office/drawing/2014/main" id="{CD20C48E-AFB8-4635-8BEF-CABCBBD1B1A4}"/>
               </a:ext>
             </a:extLst>
           </p:cNvPr>
@@ -9507,7 +9507,7 @@
           <p:cNvPr id="5" name="footer-number">
             <a:extLst xmlns:a="http://schemas.openxmlformats.org/drawingml/2006/main">
               <a:ext uri="{FF2B5EF4-FFF2-40B4-BE49-F238E27FC236}">
-                <a16:creationId xmlns:a16="http://schemas.microsoft.com/office/drawing/2014/main" id="{B372737B-B36B-4919-864A-A81A66C4C9AA}"/>
+                <a16:creationId xmlns:a16="http://schemas.microsoft.com/office/drawing/2014/main" id="{6C0EC433-60FA-47BD-8663-5F894D8FFD04}"/>
               </a:ext>
             </a:extLst>
           </p:cNvPr>
@@ -9569,7 +9569,7 @@
           <p:cNvPr id="6" name="panel-1">
             <a:extLst xmlns:a="http://schemas.openxmlformats.org/drawingml/2006/main">
               <a:ext uri="{FF2B5EF4-FFF2-40B4-BE49-F238E27FC236}">
-                <a16:creationId xmlns:a16="http://schemas.microsoft.com/office/drawing/2014/main" id="{5AD59FE9-8E16-467B-9D27-1E2677BD994F}"/>
+                <a16:creationId xmlns:a16="http://schemas.microsoft.com/office/drawing/2014/main" id="{D665BD44-4AD0-4D34-8D36-C736FC257B49}"/>
               </a:ext>
             </a:extLst>
           </p:cNvPr>
@@ -9602,7 +9602,7 @@
           <p:cNvPr id="7" name="">
             <a:extLst xmlns:a="http://schemas.openxmlformats.org/drawingml/2006/main">
               <a:ext uri="{FF2B5EF4-FFF2-40B4-BE49-F238E27FC236}">
-                <a16:creationId xmlns:a16="http://schemas.microsoft.com/office/drawing/2014/main" id="{AE7E76D6-02A0-46C2-97D8-A95360F250BB}"/>
+                <a16:creationId xmlns:a16="http://schemas.microsoft.com/office/drawing/2014/main" id="{EAE17CBE-47C3-4154-B737-DE21AAB7F69D}"/>
               </a:ext>
             </a:extLst>
           </p:cNvPr>
@@ -9664,7 +9664,7 @@
           <p:cNvPr id="8" name="">
             <a:extLst xmlns:a="http://schemas.openxmlformats.org/drawingml/2006/main">
               <a:ext uri="{FF2B5EF4-FFF2-40B4-BE49-F238E27FC236}">
-                <a16:creationId xmlns:a16="http://schemas.microsoft.com/office/drawing/2014/main" id="{819D769D-853E-4368-A2BA-0CA9C4CCF03C}"/>
+                <a16:creationId xmlns:a16="http://schemas.microsoft.com/office/drawing/2014/main" id="{FF2F9F17-AB08-4402-98C5-D9E7A6374F1C}"/>
               </a:ext>
             </a:extLst>
           </p:cNvPr>
@@ -9726,7 +9726,7 @@
           <p:cNvPr id="9" name="">
             <a:extLst xmlns:a="http://schemas.openxmlformats.org/drawingml/2006/main">
               <a:ext uri="{FF2B5EF4-FFF2-40B4-BE49-F238E27FC236}">
-                <a16:creationId xmlns:a16="http://schemas.microsoft.com/office/drawing/2014/main" id="{C3C776E9-B2C2-433D-A67B-7E842BDC6405}"/>
+                <a16:creationId xmlns:a16="http://schemas.microsoft.com/office/drawing/2014/main" id="{54F60EED-EC3C-471A-9501-A0B6C1BEC63B}"/>
               </a:ext>
             </a:extLst>
           </p:cNvPr>
@@ -9788,7 +9788,7 @@
           <p:cNvPr id="10" name="panel-2">
             <a:extLst xmlns:a="http://schemas.openxmlformats.org/drawingml/2006/main">
               <a:ext uri="{FF2B5EF4-FFF2-40B4-BE49-F238E27FC236}">
-                <a16:creationId xmlns:a16="http://schemas.microsoft.com/office/drawing/2014/main" id="{751C9C23-AA92-4330-8BA1-B2FC8051C830}"/>
+                <a16:creationId xmlns:a16="http://schemas.microsoft.com/office/drawing/2014/main" id="{05F56955-0CFD-42A6-A8A4-8B0A6A04502D}"/>
               </a:ext>
             </a:extLst>
           </p:cNvPr>
@@ -9821,7 +9821,7 @@
           <p:cNvPr id="11" name="">
             <a:extLst xmlns:a="http://schemas.openxmlformats.org/drawingml/2006/main">
               <a:ext uri="{FF2B5EF4-FFF2-40B4-BE49-F238E27FC236}">
-                <a16:creationId xmlns:a16="http://schemas.microsoft.com/office/drawing/2014/main" id="{0B0303AE-F59F-4CF3-8D71-249C3F7FF0A6}"/>
+                <a16:creationId xmlns:a16="http://schemas.microsoft.com/office/drawing/2014/main" id="{7EEBB96E-FD3C-47A3-940C-D06782E2C1FE}"/>
               </a:ext>
             </a:extLst>
           </p:cNvPr>
@@ -9883,7 +9883,7 @@
           <p:cNvPr id="12" name="">
             <a:extLst xmlns:a="http://schemas.openxmlformats.org/drawingml/2006/main">
               <a:ext uri="{FF2B5EF4-FFF2-40B4-BE49-F238E27FC236}">
-                <a16:creationId xmlns:a16="http://schemas.microsoft.com/office/drawing/2014/main" id="{222E04F7-A508-4372-AF5C-2EB069345F15}"/>
+                <a16:creationId xmlns:a16="http://schemas.microsoft.com/office/drawing/2014/main" id="{B0A975BD-3135-4A5A-960A-B7485941B48F}"/>
               </a:ext>
             </a:extLst>
           </p:cNvPr>
@@ -9945,7 +9945,7 @@
           <p:cNvPr id="13" name="">
             <a:extLst xmlns:a="http://schemas.openxmlformats.org/drawingml/2006/main">
               <a:ext uri="{FF2B5EF4-FFF2-40B4-BE49-F238E27FC236}">
-                <a16:creationId xmlns:a16="http://schemas.microsoft.com/office/drawing/2014/main" id="{6E4E77C1-0E65-4CE4-B78A-455EFCFB4B81}"/>
+                <a16:creationId xmlns:a16="http://schemas.microsoft.com/office/drawing/2014/main" id="{80554665-DE8B-4E30-8DFC-57E50ED30F61}"/>
               </a:ext>
             </a:extLst>
           </p:cNvPr>
@@ -10007,7 +10007,7 @@
           <p:cNvPr id="14" name="">
             <a:extLst xmlns:a="http://schemas.openxmlformats.org/drawingml/2006/main">
               <a:ext uri="{FF2B5EF4-FFF2-40B4-BE49-F238E27FC236}">
-                <a16:creationId xmlns:a16="http://schemas.microsoft.com/office/drawing/2014/main" id="{8E11171D-DC52-4A1C-826B-B5DB6462D627}"/>
+                <a16:creationId xmlns:a16="http://schemas.microsoft.com/office/drawing/2014/main" id="{61041E66-32BF-45F5-ADF9-DA5CBE7D377C}"/>
               </a:ext>
             </a:extLst>
           </p:cNvPr>
@@ -10067,7 +10067,7 @@
     </p:spTree>
     <p:extLst>
       <p:ext uri="{BB962C8B-B14F-4D97-AF65-F5344CB8AC3E}">
-        <p14:creationId xmlns:p14="http://schemas.microsoft.com/office/powerpoint/2010/main" val="414908589"/>
+        <p14:creationId xmlns:p14="http://schemas.microsoft.com/office/powerpoint/2010/main" val="1507347085"/>
       </p:ext>
     </p:extLst>
   </p:cSld>
@@ -10098,7 +10098,7 @@
           <p:cNvPr id="11" name="">
             <a:extLst xmlns:a="http://schemas.openxmlformats.org/drawingml/2006/main">
               <a:ext uri="{FF2B5EF4-FFF2-40B4-BE49-F238E27FC236}">
-                <a16:creationId xmlns:a16="http://schemas.microsoft.com/office/drawing/2014/main" id="{9BE2CD63-69A9-41E6-A7C5-A5FC10B4D67A}"/>
+                <a16:creationId xmlns:a16="http://schemas.microsoft.com/office/drawing/2014/main" id="{6F788EF7-477E-4D0A-9F81-3A9E95906BBD}"/>
               </a:ext>
             </a:extLst>
           </p:cNvPr>
@@ -10160,7 +10160,7 @@
           <p:cNvPr id="2" name="bullet-mark-1">
             <a:extLst xmlns:a="http://schemas.openxmlformats.org/drawingml/2006/main">
               <a:ext uri="{FF2B5EF4-FFF2-40B4-BE49-F238E27FC236}">
-                <a16:creationId xmlns:a16="http://schemas.microsoft.com/office/drawing/2014/main" id="{49A63365-0D5D-4B30-860C-18CB7A054F09}"/>
+                <a16:creationId xmlns:a16="http://schemas.microsoft.com/office/drawing/2014/main" id="{AC8EC1B9-3100-4F8A-B85C-B47434AABE8C}"/>
               </a:ext>
             </a:extLst>
           </p:cNvPr>
@@ -10222,7 +10222,7 @@
           <p:cNvPr id="3" name="bullet-1">
             <a:extLst xmlns:a="http://schemas.openxmlformats.org/drawingml/2006/main">
               <a:ext uri="{FF2B5EF4-FFF2-40B4-BE49-F238E27FC236}">
-                <a16:creationId xmlns:a16="http://schemas.microsoft.com/office/drawing/2014/main" id="{90995AF3-1AED-45DD-B73A-ED6DA8744193}"/>
+                <a16:creationId xmlns:a16="http://schemas.microsoft.com/office/drawing/2014/main" id="{83519EA9-01C7-4B88-981C-4A0D4D26C652}"/>
               </a:ext>
             </a:extLst>
           </p:cNvPr>
@@ -10284,7 +10284,7 @@
           <p:cNvPr id="4" name="bullet-mark-2">
             <a:extLst xmlns:a="http://schemas.openxmlformats.org/drawingml/2006/main">
               <a:ext uri="{FF2B5EF4-FFF2-40B4-BE49-F238E27FC236}">
-                <a16:creationId xmlns:a16="http://schemas.microsoft.com/office/drawing/2014/main" id="{3AC08ACF-E74B-4477-BC8E-D4D82DE2887A}"/>
+                <a16:creationId xmlns:a16="http://schemas.microsoft.com/office/drawing/2014/main" id="{45EE87B8-3FCC-4F2A-AF93-0B7D9B200D19}"/>
               </a:ext>
             </a:extLst>
           </p:cNvPr>
@@ -10346,7 +10346,7 @@
           <p:cNvPr id="5" name="bullet-2">
             <a:extLst xmlns:a="http://schemas.openxmlformats.org/drawingml/2006/main">
               <a:ext uri="{FF2B5EF4-FFF2-40B4-BE49-F238E27FC236}">
-                <a16:creationId xmlns:a16="http://schemas.microsoft.com/office/drawing/2014/main" id="{76FDB0A1-D10B-4F8D-9495-23443104CE59}"/>
+                <a16:creationId xmlns:a16="http://schemas.microsoft.com/office/drawing/2014/main" id="{9AFC3E91-500F-475B-B783-E21A59AFF881}"/>
               </a:ext>
             </a:extLst>
           </p:cNvPr>
@@ -10408,7 +10408,7 @@
           <p:cNvPr id="6" name="bullet-mark-3">
             <a:extLst xmlns:a="http://schemas.openxmlformats.org/drawingml/2006/main">
               <a:ext uri="{FF2B5EF4-FFF2-40B4-BE49-F238E27FC236}">
-                <a16:creationId xmlns:a16="http://schemas.microsoft.com/office/drawing/2014/main" id="{6C02C4BC-F932-4A48-B896-405F816CF9CE}"/>
+                <a16:creationId xmlns:a16="http://schemas.microsoft.com/office/drawing/2014/main" id="{41E71471-6487-4335-AF56-C6EE9B6BC9D9}"/>
               </a:ext>
             </a:extLst>
           </p:cNvPr>
@@ -10470,7 +10470,7 @@
           <p:cNvPr id="7" name="bullet-3">
             <a:extLst xmlns:a="http://schemas.openxmlformats.org/drawingml/2006/main">
               <a:ext uri="{FF2B5EF4-FFF2-40B4-BE49-F238E27FC236}">
-                <a16:creationId xmlns:a16="http://schemas.microsoft.com/office/drawing/2014/main" id="{09C56B23-3306-4587-9512-4B942C3E613C}"/>
+                <a16:creationId xmlns:a16="http://schemas.microsoft.com/office/drawing/2014/main" id="{752B32C1-0659-4AEA-AE7E-79AAEC703C3C}"/>
               </a:ext>
             </a:extLst>
           </p:cNvPr>
@@ -10532,7 +10532,7 @@
           <p:cNvPr id="8" name="bullet-mark-4">
             <a:extLst xmlns:a="http://schemas.openxmlformats.org/drawingml/2006/main">
               <a:ext uri="{FF2B5EF4-FFF2-40B4-BE49-F238E27FC236}">
-                <a16:creationId xmlns:a16="http://schemas.microsoft.com/office/drawing/2014/main" id="{9E774001-66F4-4335-B6E5-A01E4095FA6F}"/>
+                <a16:creationId xmlns:a16="http://schemas.microsoft.com/office/drawing/2014/main" id="{931F1D5F-F72D-4640-8FBF-13F2C56E6FEC}"/>
               </a:ext>
             </a:extLst>
           </p:cNvPr>
@@ -10594,7 +10594,7 @@
           <p:cNvPr id="9" name="bullet-4">
             <a:extLst xmlns:a="http://schemas.openxmlformats.org/drawingml/2006/main">
               <a:ext uri="{FF2B5EF4-FFF2-40B4-BE49-F238E27FC236}">
-                <a16:creationId xmlns:a16="http://schemas.microsoft.com/office/drawing/2014/main" id="{E9143C11-A42D-42B3-979E-B54EA6584967}"/>
+                <a16:creationId xmlns:a16="http://schemas.microsoft.com/office/drawing/2014/main" id="{B8AA546B-A168-456A-86FB-CA3437459609}"/>
               </a:ext>
             </a:extLst>
           </p:cNvPr>
@@ -10656,7 +10656,7 @@
           <p:cNvPr id="10" name="">
             <a:extLst xmlns:a="http://schemas.openxmlformats.org/drawingml/2006/main">
               <a:ext uri="{FF2B5EF4-FFF2-40B4-BE49-F238E27FC236}">
-                <a16:creationId xmlns:a16="http://schemas.microsoft.com/office/drawing/2014/main" id="{6C17CD99-46DE-4714-BFD3-9B2B9C583B9E}"/>
+                <a16:creationId xmlns:a16="http://schemas.microsoft.com/office/drawing/2014/main" id="{17424EDF-F170-495D-9BDC-CEDBDFE2C25F}"/>
               </a:ext>
             </a:extLst>
           </p:cNvPr>
@@ -10716,7 +10716,7 @@
     </p:spTree>
     <p:extLst>
       <p:ext uri="{BB962C8B-B14F-4D97-AF65-F5344CB8AC3E}">
-        <p14:creationId xmlns:p14="http://schemas.microsoft.com/office/powerpoint/2010/main" val="925768718"/>
+        <p14:creationId xmlns:p14="http://schemas.microsoft.com/office/powerpoint/2010/main" val="626533443"/>
       </p:ext>
     </p:extLst>
   </p:cSld>
@@ -10747,7 +10747,7 @@
           <p:cNvPr id="4" name="">
             <a:extLst xmlns:a="http://schemas.openxmlformats.org/drawingml/2006/main">
               <a:ext uri="{FF2B5EF4-FFF2-40B4-BE49-F238E27FC236}">
-                <a16:creationId xmlns:a16="http://schemas.microsoft.com/office/drawing/2014/main" id="{08B450A4-DFB8-42AA-BC70-F9A98129F252}"/>
+                <a16:creationId xmlns:a16="http://schemas.microsoft.com/office/drawing/2014/main" id="{97C1FD96-B33B-4CCA-826C-BC9C2311DBDC}"/>
               </a:ext>
             </a:extLst>
           </p:cNvPr>
@@ -10809,7 +10809,7 @@
           <p:cNvPr id="2" name="">
             <a:extLst xmlns:a="http://schemas.openxmlformats.org/drawingml/2006/main">
               <a:ext uri="{FF2B5EF4-FFF2-40B4-BE49-F238E27FC236}">
-                <a16:creationId xmlns:a16="http://schemas.microsoft.com/office/drawing/2014/main" id="{8EC7BE6D-D822-4D13-AA3C-121BF3867DE4}"/>
+                <a16:creationId xmlns:a16="http://schemas.microsoft.com/office/drawing/2014/main" id="{DDFC44C3-C3F2-4E8B-8E66-E38121FA42BE}"/>
               </a:ext>
             </a:extLst>
           </p:cNvPr>
@@ -10871,7 +10871,7 @@
           <p:cNvPr id="3" name="big-statement">
             <a:extLst xmlns:a="http://schemas.openxmlformats.org/drawingml/2006/main">
               <a:ext uri="{FF2B5EF4-FFF2-40B4-BE49-F238E27FC236}">
-                <a16:creationId xmlns:a16="http://schemas.microsoft.com/office/drawing/2014/main" id="{1A2AC90F-2929-46F5-8DC5-65EC57042131}"/>
+                <a16:creationId xmlns:a16="http://schemas.microsoft.com/office/drawing/2014/main" id="{B4211BEB-77AE-4793-A07B-5921B5952F7D}"/>
               </a:ext>
             </a:extLst>
           </p:cNvPr>
@@ -10931,7 +10931,7 @@
     </p:spTree>
     <p:extLst>
       <p:ext uri="{BB962C8B-B14F-4D97-AF65-F5344CB8AC3E}">
-        <p14:creationId xmlns:p14="http://schemas.microsoft.com/office/powerpoint/2010/main" val="1614634615"/>
+        <p14:creationId xmlns:p14="http://schemas.microsoft.com/office/powerpoint/2010/main" val="317178739"/>
       </p:ext>
     </p:extLst>
   </p:cSld>
@@ -10962,7 +10962,7 @@
           <p:cNvPr id="17" name="chapter-label">
             <a:extLst xmlns:a="http://schemas.openxmlformats.org/drawingml/2006/main">
               <a:ext uri="{FF2B5EF4-FFF2-40B4-BE49-F238E27FC236}">
-                <a16:creationId xmlns:a16="http://schemas.microsoft.com/office/drawing/2014/main" id="{F56C4DED-9A31-4C26-A39E-9F2567956F6E}"/>
+                <a16:creationId xmlns:a16="http://schemas.microsoft.com/office/drawing/2014/main" id="{7C8C7A9E-5A68-4199-9B2A-E2D42CC66C65}"/>
               </a:ext>
             </a:extLst>
           </p:cNvPr>
@@ -11024,7 +11024,7 @@
           <p:cNvPr id="2" name="slide-title">
             <a:extLst xmlns:a="http://schemas.openxmlformats.org/drawingml/2006/main">
               <a:ext uri="{FF2B5EF4-FFF2-40B4-BE49-F238E27FC236}">
-                <a16:creationId xmlns:a16="http://schemas.microsoft.com/office/drawing/2014/main" id="{588C9ADC-8731-48CF-880A-D70F96B43978}"/>
+                <a16:creationId xmlns:a16="http://schemas.microsoft.com/office/drawing/2014/main" id="{6C080BBB-EDF9-4BAD-9D98-ACC2FB27DDC3}"/>
               </a:ext>
             </a:extLst>
           </p:cNvPr>
@@ -11086,7 +11086,7 @@
           <p:cNvPr id="3" name="footer-rule">
             <a:extLst xmlns:a="http://schemas.openxmlformats.org/drawingml/2006/main">
               <a:ext uri="{FF2B5EF4-FFF2-40B4-BE49-F238E27FC236}">
-                <a16:creationId xmlns:a16="http://schemas.microsoft.com/office/drawing/2014/main" id="{381E0787-0645-43CB-B6EC-4F89A105398C}"/>
+                <a16:creationId xmlns:a16="http://schemas.microsoft.com/office/drawing/2014/main" id="{27EB5366-84CB-47F6-9E17-D20C50BCDC7B}"/>
               </a:ext>
             </a:extLst>
           </p:cNvPr>
@@ -11117,7 +11117,7 @@
           <p:cNvPr id="4" name="footer-book">
             <a:extLst xmlns:a="http://schemas.openxmlformats.org/drawingml/2006/main">
               <a:ext uri="{FF2B5EF4-FFF2-40B4-BE49-F238E27FC236}">
-                <a16:creationId xmlns:a16="http://schemas.microsoft.com/office/drawing/2014/main" id="{BF76F871-018B-4859-B9D7-C1E2FA80BB36}"/>
+                <a16:creationId xmlns:a16="http://schemas.microsoft.com/office/drawing/2014/main" id="{632EACB6-1F37-4956-804D-62B498A0D9F9}"/>
               </a:ext>
             </a:extLst>
           </p:cNvPr>
@@ -11179,7 +11179,7 @@
           <p:cNvPr id="5" name="footer-number">
             <a:extLst xmlns:a="http://schemas.openxmlformats.org/drawingml/2006/main">
               <a:ext uri="{FF2B5EF4-FFF2-40B4-BE49-F238E27FC236}">
-                <a16:creationId xmlns:a16="http://schemas.microsoft.com/office/drawing/2014/main" id="{7221A8DD-D3E9-485D-81A5-51D5F9B9A19A}"/>
+                <a16:creationId xmlns:a16="http://schemas.microsoft.com/office/drawing/2014/main" id="{30DED060-B41B-4985-8F87-8BB2CC512A09}"/>
               </a:ext>
             </a:extLst>
           </p:cNvPr>
@@ -11241,7 +11241,7 @@
           <p:cNvPr id="6" name="bullet-mark-1">
             <a:extLst xmlns:a="http://schemas.openxmlformats.org/drawingml/2006/main">
               <a:ext uri="{FF2B5EF4-FFF2-40B4-BE49-F238E27FC236}">
-                <a16:creationId xmlns:a16="http://schemas.microsoft.com/office/drawing/2014/main" id="{54A44746-DBF5-48C1-980F-6209793B9382}"/>
+                <a16:creationId xmlns:a16="http://schemas.microsoft.com/office/drawing/2014/main" id="{D1317FC5-6EE4-488B-9CE8-F868B4AA43D8}"/>
               </a:ext>
             </a:extLst>
           </p:cNvPr>
@@ -11303,7 +11303,7 @@
           <p:cNvPr id="7" name="bullet-1">
             <a:extLst xmlns:a="http://schemas.openxmlformats.org/drawingml/2006/main">
               <a:ext uri="{FF2B5EF4-FFF2-40B4-BE49-F238E27FC236}">
-                <a16:creationId xmlns:a16="http://schemas.microsoft.com/office/drawing/2014/main" id="{9FD842C1-1EB4-43B9-8B4C-5E9EDE9E36EE}"/>
+                <a16:creationId xmlns:a16="http://schemas.microsoft.com/office/drawing/2014/main" id="{B0FC32A8-E3A8-4124-93C5-C9C99FFDD335}"/>
               </a:ext>
             </a:extLst>
           </p:cNvPr>
@@ -11365,7 +11365,7 @@
           <p:cNvPr id="8" name="bullet-mark-2">
             <a:extLst xmlns:a="http://schemas.openxmlformats.org/drawingml/2006/main">
               <a:ext uri="{FF2B5EF4-FFF2-40B4-BE49-F238E27FC236}">
-                <a16:creationId xmlns:a16="http://schemas.microsoft.com/office/drawing/2014/main" id="{2070636D-30CA-421A-9D01-43050015358A}"/>
+                <a16:creationId xmlns:a16="http://schemas.microsoft.com/office/drawing/2014/main" id="{857AFD94-9315-4CF0-B770-4C1A0D60F677}"/>
               </a:ext>
             </a:extLst>
           </p:cNvPr>
@@ -11427,7 +11427,7 @@
           <p:cNvPr id="9" name="bullet-2">
             <a:extLst xmlns:a="http://schemas.openxmlformats.org/drawingml/2006/main">
               <a:ext uri="{FF2B5EF4-FFF2-40B4-BE49-F238E27FC236}">
-                <a16:creationId xmlns:a16="http://schemas.microsoft.com/office/drawing/2014/main" id="{0ED42DB1-B617-46CD-8072-272DDE9257A1}"/>
+                <a16:creationId xmlns:a16="http://schemas.microsoft.com/office/drawing/2014/main" id="{519888BF-14F2-463E-BC97-0D9EAF685EFB}"/>
               </a:ext>
             </a:extLst>
           </p:cNvPr>
@@ -11489,7 +11489,7 @@
           <p:cNvPr id="10" name="bullet-mark-3">
             <a:extLst xmlns:a="http://schemas.openxmlformats.org/drawingml/2006/main">
               <a:ext uri="{FF2B5EF4-FFF2-40B4-BE49-F238E27FC236}">
-                <a16:creationId xmlns:a16="http://schemas.microsoft.com/office/drawing/2014/main" id="{6D919BE0-7475-492C-8441-D92D2E34F09F}"/>
+                <a16:creationId xmlns:a16="http://schemas.microsoft.com/office/drawing/2014/main" id="{5D38C788-D3D0-46BE-A2F7-C1D11C135A0D}"/>
               </a:ext>
             </a:extLst>
           </p:cNvPr>
@@ -11551,7 +11551,7 @@
           <p:cNvPr id="11" name="bullet-3">
             <a:extLst xmlns:a="http://schemas.openxmlformats.org/drawingml/2006/main">
               <a:ext uri="{FF2B5EF4-FFF2-40B4-BE49-F238E27FC236}">
-                <a16:creationId xmlns:a16="http://schemas.microsoft.com/office/drawing/2014/main" id="{16DD9C69-FE47-4B99-B2DE-DD56AEC42138}"/>
+                <a16:creationId xmlns:a16="http://schemas.microsoft.com/office/drawing/2014/main" id="{4CD0C1A6-6A74-4FC3-A129-1CB143AE7835}"/>
               </a:ext>
             </a:extLst>
           </p:cNvPr>
@@ -11613,7 +11613,7 @@
           <p:cNvPr id="12" name="bullet-mark-4">
             <a:extLst xmlns:a="http://schemas.openxmlformats.org/drawingml/2006/main">
               <a:ext uri="{FF2B5EF4-FFF2-40B4-BE49-F238E27FC236}">
-                <a16:creationId xmlns:a16="http://schemas.microsoft.com/office/drawing/2014/main" id="{ED51647C-2021-45BF-9BED-1DF63C82EA53}"/>
+                <a16:creationId xmlns:a16="http://schemas.microsoft.com/office/drawing/2014/main" id="{D6BB91BC-168D-4D26-B3A8-DCA0E275A573}"/>
               </a:ext>
             </a:extLst>
           </p:cNvPr>
@@ -11675,7 +11675,7 @@
           <p:cNvPr id="13" name="bullet-4">
             <a:extLst xmlns:a="http://schemas.openxmlformats.org/drawingml/2006/main">
               <a:ext uri="{FF2B5EF4-FFF2-40B4-BE49-F238E27FC236}">
-                <a16:creationId xmlns:a16="http://schemas.microsoft.com/office/drawing/2014/main" id="{650BF553-279E-44BA-9120-1675F8FFBD63}"/>
+                <a16:creationId xmlns:a16="http://schemas.microsoft.com/office/drawing/2014/main" id="{B323D466-FE1B-4D16-B40F-3C221C02D6FA}"/>
               </a:ext>
             </a:extLst>
           </p:cNvPr>
@@ -11737,7 +11737,7 @@
           <p:cNvPr id="14" name="bullet-mark-5">
             <a:extLst xmlns:a="http://schemas.openxmlformats.org/drawingml/2006/main">
               <a:ext uri="{FF2B5EF4-FFF2-40B4-BE49-F238E27FC236}">
-                <a16:creationId xmlns:a16="http://schemas.microsoft.com/office/drawing/2014/main" id="{EAAC520B-6AE8-418E-BD79-9F417039F8A4}"/>
+                <a16:creationId xmlns:a16="http://schemas.microsoft.com/office/drawing/2014/main" id="{F3403A9D-C743-45C1-B6E7-6C96F42F485E}"/>
               </a:ext>
             </a:extLst>
           </p:cNvPr>
@@ -11799,7 +11799,7 @@
           <p:cNvPr id="15" name="bullet-5">
             <a:extLst xmlns:a="http://schemas.openxmlformats.org/drawingml/2006/main">
               <a:ext uri="{FF2B5EF4-FFF2-40B4-BE49-F238E27FC236}">
-                <a16:creationId xmlns:a16="http://schemas.microsoft.com/office/drawing/2014/main" id="{4FC30AC0-9A0F-477B-B28E-B1F7506087C6}"/>
+                <a16:creationId xmlns:a16="http://schemas.microsoft.com/office/drawing/2014/main" id="{7ED67FED-252F-4D6F-8589-CCC8DD180A13}"/>
               </a:ext>
             </a:extLst>
           </p:cNvPr>
@@ -11861,7 +11861,7 @@
           <p:cNvPr id="16" name="">
             <a:extLst xmlns:a="http://schemas.openxmlformats.org/drawingml/2006/main">
               <a:ext uri="{FF2B5EF4-FFF2-40B4-BE49-F238E27FC236}">
-                <a16:creationId xmlns:a16="http://schemas.microsoft.com/office/drawing/2014/main" id="{ACAAACDE-F001-4B9A-BDBF-532AE3C94073}"/>
+                <a16:creationId xmlns:a16="http://schemas.microsoft.com/office/drawing/2014/main" id="{C63F4FDE-62CE-414C-A9C3-710366E714E5}"/>
               </a:ext>
             </a:extLst>
           </p:cNvPr>
@@ -11921,7 +11921,7 @@
     </p:spTree>
     <p:extLst>
       <p:ext uri="{BB962C8B-B14F-4D97-AF65-F5344CB8AC3E}">
-        <p14:creationId xmlns:p14="http://schemas.microsoft.com/office/powerpoint/2010/main" val="147648325"/>
+        <p14:creationId xmlns:p14="http://schemas.microsoft.com/office/powerpoint/2010/main" val="583011287"/>
       </p:ext>
     </p:extLst>
   </p:cSld>
@@ -11952,7 +11952,7 @@
           <p:cNvPr id="15" name="chapter-label">
             <a:extLst xmlns:a="http://schemas.openxmlformats.org/drawingml/2006/main">
               <a:ext uri="{FF2B5EF4-FFF2-40B4-BE49-F238E27FC236}">
-                <a16:creationId xmlns:a16="http://schemas.microsoft.com/office/drawing/2014/main" id="{19547A3D-C107-4487-8BFC-B94BC62A4E06}"/>
+                <a16:creationId xmlns:a16="http://schemas.microsoft.com/office/drawing/2014/main" id="{D0937C10-F135-47B1-AF79-155B2C1ED090}"/>
               </a:ext>
             </a:extLst>
           </p:cNvPr>
@@ -12014,7 +12014,7 @@
           <p:cNvPr id="2" name="slide-title">
             <a:extLst xmlns:a="http://schemas.openxmlformats.org/drawingml/2006/main">
               <a:ext uri="{FF2B5EF4-FFF2-40B4-BE49-F238E27FC236}">
-                <a16:creationId xmlns:a16="http://schemas.microsoft.com/office/drawing/2014/main" id="{2DB9220F-DBC5-4953-889E-65095F0C286C}"/>
+                <a16:creationId xmlns:a16="http://schemas.microsoft.com/office/drawing/2014/main" id="{3B9073EC-BAB8-4626-B7B1-8CB5DCDD1366}"/>
               </a:ext>
             </a:extLst>
           </p:cNvPr>
@@ -12076,7 +12076,7 @@
           <p:cNvPr id="3" name="footer-rule">
             <a:extLst xmlns:a="http://schemas.openxmlformats.org/drawingml/2006/main">
               <a:ext uri="{FF2B5EF4-FFF2-40B4-BE49-F238E27FC236}">
-                <a16:creationId xmlns:a16="http://schemas.microsoft.com/office/drawing/2014/main" id="{25AAE608-774F-48A5-91ED-DD3C50949090}"/>
+                <a16:creationId xmlns:a16="http://schemas.microsoft.com/office/drawing/2014/main" id="{F1BD592A-03C5-4B62-98D2-E5AAD83A72B4}"/>
               </a:ext>
             </a:extLst>
           </p:cNvPr>
@@ -12107,7 +12107,7 @@
           <p:cNvPr id="4" name="footer-book">
             <a:extLst xmlns:a="http://schemas.openxmlformats.org/drawingml/2006/main">
               <a:ext uri="{FF2B5EF4-FFF2-40B4-BE49-F238E27FC236}">
-                <a16:creationId xmlns:a16="http://schemas.microsoft.com/office/drawing/2014/main" id="{BA7D1450-DB27-4AE3-BA63-A730BF963894}"/>
+                <a16:creationId xmlns:a16="http://schemas.microsoft.com/office/drawing/2014/main" id="{35A99A88-EF59-407D-808E-91A0024ED159}"/>
               </a:ext>
             </a:extLst>
           </p:cNvPr>
@@ -12169,7 +12169,7 @@
           <p:cNvPr id="5" name="footer-number">
             <a:extLst xmlns:a="http://schemas.openxmlformats.org/drawingml/2006/main">
               <a:ext uri="{FF2B5EF4-FFF2-40B4-BE49-F238E27FC236}">
-                <a16:creationId xmlns:a16="http://schemas.microsoft.com/office/drawing/2014/main" id="{675DB41F-9789-4583-80BF-A480ECE33014}"/>
+                <a16:creationId xmlns:a16="http://schemas.microsoft.com/office/drawing/2014/main" id="{CD6D4DE4-E6E0-4EC6-9EF1-B47A692C45CD}"/>
               </a:ext>
             </a:extLst>
           </p:cNvPr>
@@ -12231,7 +12231,7 @@
           <p:cNvPr id="6" name="panel-1">
             <a:extLst xmlns:a="http://schemas.openxmlformats.org/drawingml/2006/main">
               <a:ext uri="{FF2B5EF4-FFF2-40B4-BE49-F238E27FC236}">
-                <a16:creationId xmlns:a16="http://schemas.microsoft.com/office/drawing/2014/main" id="{4C6DDA6A-E82B-4784-B76D-157AE401FCDD}"/>
+                <a16:creationId xmlns:a16="http://schemas.microsoft.com/office/drawing/2014/main" id="{F6E411A2-FBE7-4F90-B124-306CC7BC7E70}"/>
               </a:ext>
             </a:extLst>
           </p:cNvPr>
@@ -12264,7 +12264,7 @@
           <p:cNvPr id="7" name="">
             <a:extLst xmlns:a="http://schemas.openxmlformats.org/drawingml/2006/main">
               <a:ext uri="{FF2B5EF4-FFF2-40B4-BE49-F238E27FC236}">
-                <a16:creationId xmlns:a16="http://schemas.microsoft.com/office/drawing/2014/main" id="{94056F15-AF27-4842-BCC2-1D2B186075E0}"/>
+                <a16:creationId xmlns:a16="http://schemas.microsoft.com/office/drawing/2014/main" id="{5DE13AFE-2959-4951-BCB8-9694D29534E2}"/>
               </a:ext>
             </a:extLst>
           </p:cNvPr>
@@ -12326,7 +12326,7 @@
           <p:cNvPr id="8" name="">
             <a:extLst xmlns:a="http://schemas.openxmlformats.org/drawingml/2006/main">
               <a:ext uri="{FF2B5EF4-FFF2-40B4-BE49-F238E27FC236}">
-                <a16:creationId xmlns:a16="http://schemas.microsoft.com/office/drawing/2014/main" id="{81434FEA-416E-45F1-A3C6-4E7E253F8E8A}"/>
+                <a16:creationId xmlns:a16="http://schemas.microsoft.com/office/drawing/2014/main" id="{BA02A203-ECAD-410F-96B3-1658C87A3B7A}"/>
               </a:ext>
             </a:extLst>
           </p:cNvPr>
@@ -12388,7 +12388,7 @@
           <p:cNvPr id="9" name="">
             <a:extLst xmlns:a="http://schemas.openxmlformats.org/drawingml/2006/main">
               <a:ext uri="{FF2B5EF4-FFF2-40B4-BE49-F238E27FC236}">
-                <a16:creationId xmlns:a16="http://schemas.microsoft.com/office/drawing/2014/main" id="{F2B8AB6A-2A8C-416D-A2C1-34FACB9CE551}"/>
+                <a16:creationId xmlns:a16="http://schemas.microsoft.com/office/drawing/2014/main" id="{6231E2B4-9724-46F8-A267-7B47AC48F68C}"/>
               </a:ext>
             </a:extLst>
           </p:cNvPr>
@@ -12450,7 +12450,7 @@
           <p:cNvPr id="10" name="panel-2">
             <a:extLst xmlns:a="http://schemas.openxmlformats.org/drawingml/2006/main">
               <a:ext uri="{FF2B5EF4-FFF2-40B4-BE49-F238E27FC236}">
-                <a16:creationId xmlns:a16="http://schemas.microsoft.com/office/drawing/2014/main" id="{4D67CAF7-D35E-49CC-8D02-F22192AFE171}"/>
+                <a16:creationId xmlns:a16="http://schemas.microsoft.com/office/drawing/2014/main" id="{01783DB5-C880-4E82-84A2-545C077C3617}"/>
               </a:ext>
             </a:extLst>
           </p:cNvPr>
@@ -12483,7 +12483,7 @@
           <p:cNvPr id="11" name="">
             <a:extLst xmlns:a="http://schemas.openxmlformats.org/drawingml/2006/main">
               <a:ext uri="{FF2B5EF4-FFF2-40B4-BE49-F238E27FC236}">
-                <a16:creationId xmlns:a16="http://schemas.microsoft.com/office/drawing/2014/main" id="{07273B10-F67C-40D5-A283-31756A541AA5}"/>
+                <a16:creationId xmlns:a16="http://schemas.microsoft.com/office/drawing/2014/main" id="{9A114A6B-92CC-4FB6-8343-D7CC00B4E5FC}"/>
               </a:ext>
             </a:extLst>
           </p:cNvPr>
@@ -12545,7 +12545,7 @@
           <p:cNvPr id="12" name="">
             <a:extLst xmlns:a="http://schemas.openxmlformats.org/drawingml/2006/main">
               <a:ext uri="{FF2B5EF4-FFF2-40B4-BE49-F238E27FC236}">
-                <a16:creationId xmlns:a16="http://schemas.microsoft.com/office/drawing/2014/main" id="{7BCEFBAF-56D2-401F-9962-4C991B4E984C}"/>
+                <a16:creationId xmlns:a16="http://schemas.microsoft.com/office/drawing/2014/main" id="{231CB11A-EA5A-4356-AC47-B94EC39F0DAD}"/>
               </a:ext>
             </a:extLst>
           </p:cNvPr>
@@ -12607,7 +12607,7 @@
           <p:cNvPr id="13" name="">
             <a:extLst xmlns:a="http://schemas.openxmlformats.org/drawingml/2006/main">
               <a:ext uri="{FF2B5EF4-FFF2-40B4-BE49-F238E27FC236}">
-                <a16:creationId xmlns:a16="http://schemas.microsoft.com/office/drawing/2014/main" id="{823C967C-BAF7-488E-81D9-5CD2BF85D104}"/>
+                <a16:creationId xmlns:a16="http://schemas.microsoft.com/office/drawing/2014/main" id="{40CEAD45-0931-405B-8ED4-BC67916BDB60}"/>
               </a:ext>
             </a:extLst>
           </p:cNvPr>
@@ -12669,7 +12669,7 @@
           <p:cNvPr id="14" name="">
             <a:extLst xmlns:a="http://schemas.openxmlformats.org/drawingml/2006/main">
               <a:ext uri="{FF2B5EF4-FFF2-40B4-BE49-F238E27FC236}">
-                <a16:creationId xmlns:a16="http://schemas.microsoft.com/office/drawing/2014/main" id="{F9BF9614-8AED-4927-A757-77FA4A586551}"/>
+                <a16:creationId xmlns:a16="http://schemas.microsoft.com/office/drawing/2014/main" id="{EAE1CB4B-6AF7-4C2A-AA77-7AC80663DCDF}"/>
               </a:ext>
             </a:extLst>
           </p:cNvPr>
@@ -12729,7 +12729,7 @@
     </p:spTree>
     <p:extLst>
       <p:ext uri="{BB962C8B-B14F-4D97-AF65-F5344CB8AC3E}">
-        <p14:creationId xmlns:p14="http://schemas.microsoft.com/office/powerpoint/2010/main" val="1426665851"/>
+        <p14:creationId xmlns:p14="http://schemas.microsoft.com/office/powerpoint/2010/main" val="1195729902"/>
       </p:ext>
     </p:extLst>
   </p:cSld>
@@ -12760,7 +12760,7 @@
           <p:cNvPr id="18" name="chapter-label">
             <a:extLst xmlns:a="http://schemas.openxmlformats.org/drawingml/2006/main">
               <a:ext uri="{FF2B5EF4-FFF2-40B4-BE49-F238E27FC236}">
-                <a16:creationId xmlns:a16="http://schemas.microsoft.com/office/drawing/2014/main" id="{512FE7B3-695F-4967-8445-13FDF43CB549}"/>
+                <a16:creationId xmlns:a16="http://schemas.microsoft.com/office/drawing/2014/main" id="{6BC7C339-0DAD-4992-BC1B-11256ECFBF5C}"/>
               </a:ext>
             </a:extLst>
           </p:cNvPr>
@@ -12822,7 +12822,7 @@
           <p:cNvPr id="2" name="slide-title">
             <a:extLst xmlns:a="http://schemas.openxmlformats.org/drawingml/2006/main">
               <a:ext uri="{FF2B5EF4-FFF2-40B4-BE49-F238E27FC236}">
-                <a16:creationId xmlns:a16="http://schemas.microsoft.com/office/drawing/2014/main" id="{EF5F689B-B51C-4C41-B242-9C6FB5CBD398}"/>
+                <a16:creationId xmlns:a16="http://schemas.microsoft.com/office/drawing/2014/main" id="{AE9475B6-334E-40B3-B6A8-CA2F4F28B9A7}"/>
               </a:ext>
             </a:extLst>
           </p:cNvPr>
@@ -12884,7 +12884,7 @@
           <p:cNvPr id="3" name="footer-rule">
             <a:extLst xmlns:a="http://schemas.openxmlformats.org/drawingml/2006/main">
               <a:ext uri="{FF2B5EF4-FFF2-40B4-BE49-F238E27FC236}">
-                <a16:creationId xmlns:a16="http://schemas.microsoft.com/office/drawing/2014/main" id="{1285AD2B-D9AF-4035-9058-CB6CCC96B1F4}"/>
+                <a16:creationId xmlns:a16="http://schemas.microsoft.com/office/drawing/2014/main" id="{F1E17E3D-D39C-4717-B78C-2085C9EFDDE5}"/>
               </a:ext>
             </a:extLst>
           </p:cNvPr>
@@ -12915,7 +12915,7 @@
           <p:cNvPr id="4" name="footer-book">
             <a:extLst xmlns:a="http://schemas.openxmlformats.org/drawingml/2006/main">
               <a:ext uri="{FF2B5EF4-FFF2-40B4-BE49-F238E27FC236}">
-                <a16:creationId xmlns:a16="http://schemas.microsoft.com/office/drawing/2014/main" id="{FB034CE0-5DF1-4D80-9842-FEA7840D5890}"/>
+                <a16:creationId xmlns:a16="http://schemas.microsoft.com/office/drawing/2014/main" id="{3D915BAF-48EF-4984-8AF5-CBD5320EFD8E}"/>
               </a:ext>
             </a:extLst>
           </p:cNvPr>
@@ -12977,7 +12977,7 @@
           <p:cNvPr id="5" name="footer-number">
             <a:extLst xmlns:a="http://schemas.openxmlformats.org/drawingml/2006/main">
               <a:ext uri="{FF2B5EF4-FFF2-40B4-BE49-F238E27FC236}">
-                <a16:creationId xmlns:a16="http://schemas.microsoft.com/office/drawing/2014/main" id="{F4A6D13C-0F44-4D84-8D0B-772DA61C238D}"/>
+                <a16:creationId xmlns:a16="http://schemas.microsoft.com/office/drawing/2014/main" id="{75062FBC-B92A-4A35-8993-EEAA30333C7A}"/>
               </a:ext>
             </a:extLst>
           </p:cNvPr>
@@ -13039,7 +13039,7 @@
           <p:cNvPr id="6" name="">
             <a:extLst xmlns:a="http://schemas.openxmlformats.org/drawingml/2006/main">
               <a:ext uri="{FF2B5EF4-FFF2-40B4-BE49-F238E27FC236}">
-                <a16:creationId xmlns:a16="http://schemas.microsoft.com/office/drawing/2014/main" id="{96CDDA60-86E6-498B-92AB-1A76DC570E58}"/>
+                <a16:creationId xmlns:a16="http://schemas.microsoft.com/office/drawing/2014/main" id="{B4612F29-7AA4-4ADE-9898-3E1F9A52157A}"/>
               </a:ext>
             </a:extLst>
           </p:cNvPr>
@@ -13101,7 +13101,7 @@
           <p:cNvPr id="7" name="bullet-mark-1">
             <a:extLst xmlns:a="http://schemas.openxmlformats.org/drawingml/2006/main">
               <a:ext uri="{FF2B5EF4-FFF2-40B4-BE49-F238E27FC236}">
-                <a16:creationId xmlns:a16="http://schemas.microsoft.com/office/drawing/2014/main" id="{63353184-6DCA-4FC6-B33B-6B72562F638C}"/>
+                <a16:creationId xmlns:a16="http://schemas.microsoft.com/office/drawing/2014/main" id="{7B177644-2B01-4D7B-9C66-BF1CD70EA5A8}"/>
               </a:ext>
             </a:extLst>
           </p:cNvPr>
@@ -13163,7 +13163,7 @@
           <p:cNvPr id="8" name="bullet-1">
             <a:extLst xmlns:a="http://schemas.openxmlformats.org/drawingml/2006/main">
               <a:ext uri="{FF2B5EF4-FFF2-40B4-BE49-F238E27FC236}">
-                <a16:creationId xmlns:a16="http://schemas.microsoft.com/office/drawing/2014/main" id="{48D761E7-12C0-47CB-972B-392B281ED5D3}"/>
+                <a16:creationId xmlns:a16="http://schemas.microsoft.com/office/drawing/2014/main" id="{FF2FD7C1-A3E0-491A-8BAC-242A03A84100}"/>
               </a:ext>
             </a:extLst>
           </p:cNvPr>
@@ -13225,7 +13225,7 @@
           <p:cNvPr id="9" name="bullet-mark-2">
             <a:extLst xmlns:a="http://schemas.openxmlformats.org/drawingml/2006/main">
               <a:ext uri="{FF2B5EF4-FFF2-40B4-BE49-F238E27FC236}">
-                <a16:creationId xmlns:a16="http://schemas.microsoft.com/office/drawing/2014/main" id="{56C074D5-FD91-4B76-BBB4-5F520EB5E02C}"/>
+                <a16:creationId xmlns:a16="http://schemas.microsoft.com/office/drawing/2014/main" id="{106DA331-B3F2-4934-B18D-CD38D960A926}"/>
               </a:ext>
             </a:extLst>
           </p:cNvPr>
@@ -13287,7 +13287,7 @@
           <p:cNvPr id="10" name="bullet-2">
             <a:extLst xmlns:a="http://schemas.openxmlformats.org/drawingml/2006/main">
               <a:ext uri="{FF2B5EF4-FFF2-40B4-BE49-F238E27FC236}">
-                <a16:creationId xmlns:a16="http://schemas.microsoft.com/office/drawing/2014/main" id="{5E4F7BB4-9EC4-4E6B-9DFD-3A440D83F5F2}"/>
+                <a16:creationId xmlns:a16="http://schemas.microsoft.com/office/drawing/2014/main" id="{3C8647C5-E2DC-4D49-9492-58A6065A01BE}"/>
               </a:ext>
             </a:extLst>
           </p:cNvPr>
@@ -13349,7 +13349,7 @@
           <p:cNvPr id="11" name="bullet-mark-3">
             <a:extLst xmlns:a="http://schemas.openxmlformats.org/drawingml/2006/main">
               <a:ext uri="{FF2B5EF4-FFF2-40B4-BE49-F238E27FC236}">
-                <a16:creationId xmlns:a16="http://schemas.microsoft.com/office/drawing/2014/main" id="{AB389203-35BF-4A36-B60C-A0571E368FCE}"/>
+                <a16:creationId xmlns:a16="http://schemas.microsoft.com/office/drawing/2014/main" id="{5C2A055E-FF21-4AD8-96D1-E7A0ACFC9830}"/>
               </a:ext>
             </a:extLst>
           </p:cNvPr>
@@ -13411,7 +13411,7 @@
           <p:cNvPr id="12" name="bullet-3">
             <a:extLst xmlns:a="http://schemas.openxmlformats.org/drawingml/2006/main">
               <a:ext uri="{FF2B5EF4-FFF2-40B4-BE49-F238E27FC236}">
-                <a16:creationId xmlns:a16="http://schemas.microsoft.com/office/drawing/2014/main" id="{5D23755E-D2BD-4C5F-81CC-1D0E187DD41C}"/>
+                <a16:creationId xmlns:a16="http://schemas.microsoft.com/office/drawing/2014/main" id="{DC7D487E-D02F-4957-A8A6-6E636B0ECE06}"/>
               </a:ext>
             </a:extLst>
           </p:cNvPr>
@@ -13473,7 +13473,7 @@
           <p:cNvPr id="13" name="bullet-mark-4">
             <a:extLst xmlns:a="http://schemas.openxmlformats.org/drawingml/2006/main">
               <a:ext uri="{FF2B5EF4-FFF2-40B4-BE49-F238E27FC236}">
-                <a16:creationId xmlns:a16="http://schemas.microsoft.com/office/drawing/2014/main" id="{2AB183F3-22DE-4CA6-B817-C51E756A9084}"/>
+                <a16:creationId xmlns:a16="http://schemas.microsoft.com/office/drawing/2014/main" id="{072540EE-A5A0-4336-9691-5AA763DB7989}"/>
               </a:ext>
             </a:extLst>
           </p:cNvPr>
@@ -13535,7 +13535,7 @@
           <p:cNvPr id="14" name="bullet-4">
             <a:extLst xmlns:a="http://schemas.openxmlformats.org/drawingml/2006/main">
               <a:ext uri="{FF2B5EF4-FFF2-40B4-BE49-F238E27FC236}">
-                <a16:creationId xmlns:a16="http://schemas.microsoft.com/office/drawing/2014/main" id="{63A0392C-F01D-4B2E-B57B-F28AFD6B0118}"/>
+                <a16:creationId xmlns:a16="http://schemas.microsoft.com/office/drawing/2014/main" id="{E9F6E92C-4ECD-4084-8E88-2C53418517C4}"/>
               </a:ext>
             </a:extLst>
           </p:cNvPr>
@@ -13597,7 +13597,7 @@
           <p:cNvPr id="15" name="bullet-mark-5">
             <a:extLst xmlns:a="http://schemas.openxmlformats.org/drawingml/2006/main">
               <a:ext uri="{FF2B5EF4-FFF2-40B4-BE49-F238E27FC236}">
-                <a16:creationId xmlns:a16="http://schemas.microsoft.com/office/drawing/2014/main" id="{97BAA6E1-73B0-4A4C-ADBD-CAB54F5E4BD2}"/>
+                <a16:creationId xmlns:a16="http://schemas.microsoft.com/office/drawing/2014/main" id="{26070E74-1749-4F25-9BD5-3159631F7EA1}"/>
               </a:ext>
             </a:extLst>
           </p:cNvPr>
@@ -13659,7 +13659,7 @@
           <p:cNvPr id="16" name="bullet-5">
             <a:extLst xmlns:a="http://schemas.openxmlformats.org/drawingml/2006/main">
               <a:ext uri="{FF2B5EF4-FFF2-40B4-BE49-F238E27FC236}">
-                <a16:creationId xmlns:a16="http://schemas.microsoft.com/office/drawing/2014/main" id="{1AE6D17D-1A0F-45D1-A16F-BCC964DB46A2}"/>
+                <a16:creationId xmlns:a16="http://schemas.microsoft.com/office/drawing/2014/main" id="{B8D7C4AA-5A78-4343-AD3A-DD996E3B8078}"/>
               </a:ext>
             </a:extLst>
           </p:cNvPr>
@@ -13721,7 +13721,7 @@
           <p:cNvPr id="17" name="">
             <a:extLst xmlns:a="http://schemas.openxmlformats.org/drawingml/2006/main">
               <a:ext uri="{FF2B5EF4-FFF2-40B4-BE49-F238E27FC236}">
-                <a16:creationId xmlns:a16="http://schemas.microsoft.com/office/drawing/2014/main" id="{96B7EC9D-5A79-4E3C-A0C3-AB9DA40D74EA}"/>
+                <a16:creationId xmlns:a16="http://schemas.microsoft.com/office/drawing/2014/main" id="{6BDC0497-CB67-43E1-B97A-DA207D36E649}"/>
               </a:ext>
             </a:extLst>
           </p:cNvPr>
@@ -13781,7 +13781,7 @@
     </p:spTree>
     <p:extLst>
       <p:ext uri="{BB962C8B-B14F-4D97-AF65-F5344CB8AC3E}">
-        <p14:creationId xmlns:p14="http://schemas.microsoft.com/office/powerpoint/2010/main" val="806635739"/>
+        <p14:creationId xmlns:p14="http://schemas.microsoft.com/office/powerpoint/2010/main" val="277968874"/>
       </p:ext>
     </p:extLst>
   </p:cSld>
@@ -13812,7 +13812,7 @@
           <p:cNvPr id="8" name="chapter-label">
             <a:extLst xmlns:a="http://schemas.openxmlformats.org/drawingml/2006/main">
               <a:ext uri="{FF2B5EF4-FFF2-40B4-BE49-F238E27FC236}">
-                <a16:creationId xmlns:a16="http://schemas.microsoft.com/office/drawing/2014/main" id="{6F1CD557-4E0C-4151-B006-F3B965A92F00}"/>
+                <a16:creationId xmlns:a16="http://schemas.microsoft.com/office/drawing/2014/main" id="{DA3D6A92-2C52-4A1C-997A-66A08FECC667}"/>
               </a:ext>
             </a:extLst>
           </p:cNvPr>
@@ -13874,7 +13874,7 @@
           <p:cNvPr id="2" name="slide-title">
             <a:extLst xmlns:a="http://schemas.openxmlformats.org/drawingml/2006/main">
               <a:ext uri="{FF2B5EF4-FFF2-40B4-BE49-F238E27FC236}">
-                <a16:creationId xmlns:a16="http://schemas.microsoft.com/office/drawing/2014/main" id="{F3427D91-22A9-467A-BECD-D479852B9DEE}"/>
+                <a16:creationId xmlns:a16="http://schemas.microsoft.com/office/drawing/2014/main" id="{AFC8B568-E8AC-4B81-A5E6-64A88E269A0A}"/>
               </a:ext>
             </a:extLst>
           </p:cNvPr>
@@ -13936,7 +13936,7 @@
           <p:cNvPr id="3" name="footer-rule">
             <a:extLst xmlns:a="http://schemas.openxmlformats.org/drawingml/2006/main">
               <a:ext uri="{FF2B5EF4-FFF2-40B4-BE49-F238E27FC236}">
-                <a16:creationId xmlns:a16="http://schemas.microsoft.com/office/drawing/2014/main" id="{9F400429-FCF1-4199-BED4-78A013DD71E1}"/>
+                <a16:creationId xmlns:a16="http://schemas.microsoft.com/office/drawing/2014/main" id="{955C46A1-0CE4-4CCB-8D98-8A25352008EA}"/>
               </a:ext>
             </a:extLst>
           </p:cNvPr>
@@ -13967,7 +13967,7 @@
           <p:cNvPr id="4" name="footer-book">
             <a:extLst xmlns:a="http://schemas.openxmlformats.org/drawingml/2006/main">
               <a:ext uri="{FF2B5EF4-FFF2-40B4-BE49-F238E27FC236}">
-                <a16:creationId xmlns:a16="http://schemas.microsoft.com/office/drawing/2014/main" id="{6230DE23-694B-4D9F-B7B3-D5B1CAEE456E}"/>
+                <a16:creationId xmlns:a16="http://schemas.microsoft.com/office/drawing/2014/main" id="{3D31BDAE-8767-4620-ABE4-A1056D3B58D7}"/>
               </a:ext>
             </a:extLst>
           </p:cNvPr>
@@ -14029,7 +14029,7 @@
           <p:cNvPr id="5" name="footer-number">
             <a:extLst xmlns:a="http://schemas.openxmlformats.org/drawingml/2006/main">
               <a:ext uri="{FF2B5EF4-FFF2-40B4-BE49-F238E27FC236}">
-                <a16:creationId xmlns:a16="http://schemas.microsoft.com/office/drawing/2014/main" id="{0AD8CD9B-47BD-4DE9-A94D-783F3A65A398}"/>
+                <a16:creationId xmlns:a16="http://schemas.microsoft.com/office/drawing/2014/main" id="{80796BE6-1644-467B-802D-2865E2A25169}"/>
               </a:ext>
             </a:extLst>
           </p:cNvPr>
@@ -14095,7 +14095,7 @@
           <p:nvPr/>
         </p:nvPicPr>
         <p:blipFill>
-          <a:blip xmlns:r="http://schemas.openxmlformats.org/officeDocument/2006/relationships" xmlns:a="http://schemas.openxmlformats.org/drawingml/2006/main" r:embed="R72de4c16ea914fef"/>
+          <a:blip xmlns:r="http://schemas.openxmlformats.org/officeDocument/2006/relationships" xmlns:a="http://schemas.openxmlformats.org/drawingml/2006/main" r:embed="R7c0c78c9366f4651"/>
           <a:stretch xmlns:a="http://schemas.openxmlformats.org/drawingml/2006/main"/>
         </p:blipFill>
         <p:spPr>
@@ -14113,7 +14113,7 @@
           <p:cNvPr id="7" name="">
             <a:extLst xmlns:a="http://schemas.openxmlformats.org/drawingml/2006/main">
               <a:ext uri="{FF2B5EF4-FFF2-40B4-BE49-F238E27FC236}">
-                <a16:creationId xmlns:a16="http://schemas.microsoft.com/office/drawing/2014/main" id="{3A1FF201-9F3C-4BB9-A57B-4215AE6000ED}"/>
+                <a16:creationId xmlns:a16="http://schemas.microsoft.com/office/drawing/2014/main" id="{86BB410C-14C2-4CEC-BD02-D3575B35C825}"/>
               </a:ext>
             </a:extLst>
           </p:cNvPr>
@@ -14173,7 +14173,7 @@
     </p:spTree>
     <p:extLst>
       <p:ext uri="{BB962C8B-B14F-4D97-AF65-F5344CB8AC3E}">
-        <p14:creationId xmlns:p14="http://schemas.microsoft.com/office/powerpoint/2010/main" val="820627115"/>
+        <p14:creationId xmlns:p14="http://schemas.microsoft.com/office/powerpoint/2010/main" val="775353843"/>
       </p:ext>
     </p:extLst>
   </p:cSld>
@@ -14204,7 +14204,7 @@
           <p:cNvPr id="18" name="chapter-label">
             <a:extLst xmlns:a="http://schemas.openxmlformats.org/drawingml/2006/main">
               <a:ext uri="{FF2B5EF4-FFF2-40B4-BE49-F238E27FC236}">
-                <a16:creationId xmlns:a16="http://schemas.microsoft.com/office/drawing/2014/main" id="{A95726EB-FBA0-4B72-93F0-815F1410B99A}"/>
+                <a16:creationId xmlns:a16="http://schemas.microsoft.com/office/drawing/2014/main" id="{866CFBA4-533E-4B60-904F-6313BA408D9F}"/>
               </a:ext>
             </a:extLst>
           </p:cNvPr>
@@ -14266,7 +14266,7 @@
           <p:cNvPr id="2" name="slide-title">
             <a:extLst xmlns:a="http://schemas.openxmlformats.org/drawingml/2006/main">
               <a:ext uri="{FF2B5EF4-FFF2-40B4-BE49-F238E27FC236}">
-                <a16:creationId xmlns:a16="http://schemas.microsoft.com/office/drawing/2014/main" id="{DAEC4A9C-7AD5-4DF2-BCC8-D581758048CF}"/>
+                <a16:creationId xmlns:a16="http://schemas.microsoft.com/office/drawing/2014/main" id="{E563AA75-FC3A-4A45-80CB-A77492BE60D6}"/>
               </a:ext>
             </a:extLst>
           </p:cNvPr>
@@ -14328,7 +14328,7 @@
           <p:cNvPr id="3" name="footer-rule">
             <a:extLst xmlns:a="http://schemas.openxmlformats.org/drawingml/2006/main">
               <a:ext uri="{FF2B5EF4-FFF2-40B4-BE49-F238E27FC236}">
-                <a16:creationId xmlns:a16="http://schemas.microsoft.com/office/drawing/2014/main" id="{37E7F742-6504-4E31-A44F-888599D906FF}"/>
+                <a16:creationId xmlns:a16="http://schemas.microsoft.com/office/drawing/2014/main" id="{5784FA51-DB28-4C95-9E00-C983DF044F41}"/>
               </a:ext>
             </a:extLst>
           </p:cNvPr>
@@ -14359,7 +14359,7 @@
           <p:cNvPr id="4" name="footer-book">
             <a:extLst xmlns:a="http://schemas.openxmlformats.org/drawingml/2006/main">
               <a:ext uri="{FF2B5EF4-FFF2-40B4-BE49-F238E27FC236}">
-                <a16:creationId xmlns:a16="http://schemas.microsoft.com/office/drawing/2014/main" id="{DF914DDE-112D-444A-9638-99067FF3C27F}"/>
+                <a16:creationId xmlns:a16="http://schemas.microsoft.com/office/drawing/2014/main" id="{FA0993F1-8760-4A9E-8F18-99F5CEF17EF8}"/>
               </a:ext>
             </a:extLst>
           </p:cNvPr>
@@ -14421,7 +14421,7 @@
           <p:cNvPr id="5" name="footer-number">
             <a:extLst xmlns:a="http://schemas.openxmlformats.org/drawingml/2006/main">
               <a:ext uri="{FF2B5EF4-FFF2-40B4-BE49-F238E27FC236}">
-                <a16:creationId xmlns:a16="http://schemas.microsoft.com/office/drawing/2014/main" id="{5F0129EF-8ED4-4062-84C2-852345DC8DE5}"/>
+                <a16:creationId xmlns:a16="http://schemas.microsoft.com/office/drawing/2014/main" id="{C0E12262-AF23-485D-A04C-BFEC187E4D55}"/>
               </a:ext>
             </a:extLst>
           </p:cNvPr>
@@ -14483,7 +14483,7 @@
           <p:cNvPr id="6" name="">
             <a:extLst xmlns:a="http://schemas.openxmlformats.org/drawingml/2006/main">
               <a:ext uri="{FF2B5EF4-FFF2-40B4-BE49-F238E27FC236}">
-                <a16:creationId xmlns:a16="http://schemas.microsoft.com/office/drawing/2014/main" id="{5B400CB6-6CB1-49D8-9908-05D24B8F9C44}"/>
+                <a16:creationId xmlns:a16="http://schemas.microsoft.com/office/drawing/2014/main" id="{C5BFF478-D096-4D58-8CA7-76C78F103F79}"/>
               </a:ext>
             </a:extLst>
           </p:cNvPr>
@@ -14545,7 +14545,7 @@
           <p:cNvPr id="7" name="bullet-mark-1">
             <a:extLst xmlns:a="http://schemas.openxmlformats.org/drawingml/2006/main">
               <a:ext uri="{FF2B5EF4-FFF2-40B4-BE49-F238E27FC236}">
-                <a16:creationId xmlns:a16="http://schemas.microsoft.com/office/drawing/2014/main" id="{231112DA-3FDB-44FD-946B-3696B25B74A3}"/>
+                <a16:creationId xmlns:a16="http://schemas.microsoft.com/office/drawing/2014/main" id="{02F56119-89E1-4ACE-8348-EA72AFC39949}"/>
               </a:ext>
             </a:extLst>
           </p:cNvPr>
@@ -14607,7 +14607,7 @@
           <p:cNvPr id="8" name="bullet-1">
             <a:extLst xmlns:a="http://schemas.openxmlformats.org/drawingml/2006/main">
               <a:ext uri="{FF2B5EF4-FFF2-40B4-BE49-F238E27FC236}">
-                <a16:creationId xmlns:a16="http://schemas.microsoft.com/office/drawing/2014/main" id="{4970A0F2-7BD4-4A66-ABAC-E1A947DC08E4}"/>
+                <a16:creationId xmlns:a16="http://schemas.microsoft.com/office/drawing/2014/main" id="{EE709908-C05B-4F6D-984E-336F79B65CDF}"/>
               </a:ext>
             </a:extLst>
           </p:cNvPr>
@@ -14669,7 +14669,7 @@
           <p:cNvPr id="9" name="bullet-mark-2">
             <a:extLst xmlns:a="http://schemas.openxmlformats.org/drawingml/2006/main">
               <a:ext uri="{FF2B5EF4-FFF2-40B4-BE49-F238E27FC236}">
-                <a16:creationId xmlns:a16="http://schemas.microsoft.com/office/drawing/2014/main" id="{2D9BDE1D-1DCC-413D-B53D-A37642BDF8E5}"/>
+                <a16:creationId xmlns:a16="http://schemas.microsoft.com/office/drawing/2014/main" id="{E6388121-0767-4C77-A2BD-E52186DEDB9C}"/>
               </a:ext>
             </a:extLst>
           </p:cNvPr>
@@ -14731,7 +14731,7 @@
           <p:cNvPr id="10" name="bullet-2">
             <a:extLst xmlns:a="http://schemas.openxmlformats.org/drawingml/2006/main">
               <a:ext uri="{FF2B5EF4-FFF2-40B4-BE49-F238E27FC236}">
-                <a16:creationId xmlns:a16="http://schemas.microsoft.com/office/drawing/2014/main" id="{2A06F649-EAB5-4F45-B570-BFC4942BDC7E}"/>
+                <a16:creationId xmlns:a16="http://schemas.microsoft.com/office/drawing/2014/main" id="{777F4D31-32C3-4B7C-97B6-8EDB6A4461DC}"/>
               </a:ext>
             </a:extLst>
           </p:cNvPr>
@@ -14793,7 +14793,7 @@
           <p:cNvPr id="11" name="bullet-mark-3">
             <a:extLst xmlns:a="http://schemas.openxmlformats.org/drawingml/2006/main">
               <a:ext uri="{FF2B5EF4-FFF2-40B4-BE49-F238E27FC236}">
-                <a16:creationId xmlns:a16="http://schemas.microsoft.com/office/drawing/2014/main" id="{6232699C-B7A8-4ECF-BB7F-6979349750FE}"/>
+                <a16:creationId xmlns:a16="http://schemas.microsoft.com/office/drawing/2014/main" id="{555E57DE-E3C6-4FF5-BDE7-C2C87F180D9D}"/>
               </a:ext>
             </a:extLst>
           </p:cNvPr>
@@ -14855,7 +14855,7 @@
           <p:cNvPr id="12" name="bullet-3">
             <a:extLst xmlns:a="http://schemas.openxmlformats.org/drawingml/2006/main">
               <a:ext uri="{FF2B5EF4-FFF2-40B4-BE49-F238E27FC236}">
-                <a16:creationId xmlns:a16="http://schemas.microsoft.com/office/drawing/2014/main" id="{325FE5F4-47F2-432D-ACF3-1F46BC2EAC2C}"/>
+                <a16:creationId xmlns:a16="http://schemas.microsoft.com/office/drawing/2014/main" id="{1DC3B94F-075B-4A7F-8AEF-7598B2F4F0D6}"/>
               </a:ext>
             </a:extLst>
           </p:cNvPr>
@@ -14917,7 +14917,7 @@
           <p:cNvPr id="13" name="bullet-mark-4">
             <a:extLst xmlns:a="http://schemas.openxmlformats.org/drawingml/2006/main">
               <a:ext uri="{FF2B5EF4-FFF2-40B4-BE49-F238E27FC236}">
-                <a16:creationId xmlns:a16="http://schemas.microsoft.com/office/drawing/2014/main" id="{BF4E18D1-9156-4F45-9B8D-6726C14BE5F8}"/>
+                <a16:creationId xmlns:a16="http://schemas.microsoft.com/office/drawing/2014/main" id="{02E8F529-06DB-4735-9171-B93323720F66}"/>
               </a:ext>
             </a:extLst>
           </p:cNvPr>
@@ -14979,7 +14979,7 @@
           <p:cNvPr id="14" name="bullet-4">
             <a:extLst xmlns:a="http://schemas.openxmlformats.org/drawingml/2006/main">
               <a:ext uri="{FF2B5EF4-FFF2-40B4-BE49-F238E27FC236}">
-                <a16:creationId xmlns:a16="http://schemas.microsoft.com/office/drawing/2014/main" id="{C9C3C8C5-0CFE-426A-8CD5-0CEB9ACD6727}"/>
+                <a16:creationId xmlns:a16="http://schemas.microsoft.com/office/drawing/2014/main" id="{5D318D9D-D079-4B2C-8DD4-45B51FB24A00}"/>
               </a:ext>
             </a:extLst>
           </p:cNvPr>
@@ -15041,7 +15041,7 @@
           <p:cNvPr id="15" name="bullet-mark-5">
             <a:extLst xmlns:a="http://schemas.openxmlformats.org/drawingml/2006/main">
               <a:ext uri="{FF2B5EF4-FFF2-40B4-BE49-F238E27FC236}">
-                <a16:creationId xmlns:a16="http://schemas.microsoft.com/office/drawing/2014/main" id="{1C30C8AF-C7CA-4AB6-A21C-C333B772223D}"/>
+                <a16:creationId xmlns:a16="http://schemas.microsoft.com/office/drawing/2014/main" id="{EBBFD15D-6930-456D-B538-A96A8C2DF6F9}"/>
               </a:ext>
             </a:extLst>
           </p:cNvPr>
@@ -15103,7 +15103,7 @@
           <p:cNvPr id="16" name="bullet-5">
             <a:extLst xmlns:a="http://schemas.openxmlformats.org/drawingml/2006/main">
               <a:ext uri="{FF2B5EF4-FFF2-40B4-BE49-F238E27FC236}">
-                <a16:creationId xmlns:a16="http://schemas.microsoft.com/office/drawing/2014/main" id="{903A9DDA-12C1-4F32-AC10-06779EFCC290}"/>
+                <a16:creationId xmlns:a16="http://schemas.microsoft.com/office/drawing/2014/main" id="{9DB53450-068D-4AE5-98CB-B2741521D5B0}"/>
               </a:ext>
             </a:extLst>
           </p:cNvPr>
@@ -15165,7 +15165,7 @@
           <p:cNvPr id="17" name="">
             <a:extLst xmlns:a="http://schemas.openxmlformats.org/drawingml/2006/main">
               <a:ext uri="{FF2B5EF4-FFF2-40B4-BE49-F238E27FC236}">
-                <a16:creationId xmlns:a16="http://schemas.microsoft.com/office/drawing/2014/main" id="{7827E5CA-FF8D-4299-91F3-BFBE128F8ACE}"/>
+                <a16:creationId xmlns:a16="http://schemas.microsoft.com/office/drawing/2014/main" id="{22FD8186-5715-4AA3-AD2B-EFD0C6664AA3}"/>
               </a:ext>
             </a:extLst>
           </p:cNvPr>
@@ -15225,7 +15225,7 @@
     </p:spTree>
     <p:extLst>
       <p:ext uri="{BB962C8B-B14F-4D97-AF65-F5344CB8AC3E}">
-        <p14:creationId xmlns:p14="http://schemas.microsoft.com/office/powerpoint/2010/main" val="1882350560"/>
+        <p14:creationId xmlns:p14="http://schemas.microsoft.com/office/powerpoint/2010/main" val="2020103308"/>
       </p:ext>
     </p:extLst>
   </p:cSld>
@@ -15256,7 +15256,7 @@
           <p:cNvPr id="8" name="chapter-label">
             <a:extLst xmlns:a="http://schemas.openxmlformats.org/drawingml/2006/main">
               <a:ext uri="{FF2B5EF4-FFF2-40B4-BE49-F238E27FC236}">
-                <a16:creationId xmlns:a16="http://schemas.microsoft.com/office/drawing/2014/main" id="{932A1036-D24D-48CB-880B-0EDF3DF33170}"/>
+                <a16:creationId xmlns:a16="http://schemas.microsoft.com/office/drawing/2014/main" id="{ED820D55-D709-4A34-B832-C143B4956D72}"/>
               </a:ext>
             </a:extLst>
           </p:cNvPr>
@@ -15318,7 +15318,7 @@
           <p:cNvPr id="2" name="slide-title">
             <a:extLst xmlns:a="http://schemas.openxmlformats.org/drawingml/2006/main">
               <a:ext uri="{FF2B5EF4-FFF2-40B4-BE49-F238E27FC236}">
-                <a16:creationId xmlns:a16="http://schemas.microsoft.com/office/drawing/2014/main" id="{FBEF8F38-4009-4758-B39F-E49D56546082}"/>
+                <a16:creationId xmlns:a16="http://schemas.microsoft.com/office/drawing/2014/main" id="{17672327-C1A9-491D-B816-B16A0A52AC2A}"/>
               </a:ext>
             </a:extLst>
           </p:cNvPr>
@@ -15380,7 +15380,7 @@
           <p:cNvPr id="3" name="footer-rule">
             <a:extLst xmlns:a="http://schemas.openxmlformats.org/drawingml/2006/main">
               <a:ext uri="{FF2B5EF4-FFF2-40B4-BE49-F238E27FC236}">
-                <a16:creationId xmlns:a16="http://schemas.microsoft.com/office/drawing/2014/main" id="{73D737EE-EB66-4587-87A7-FED7E5DBD1CF}"/>
+                <a16:creationId xmlns:a16="http://schemas.microsoft.com/office/drawing/2014/main" id="{030F6A64-EBF0-4319-B76D-12042F85D3F0}"/>
               </a:ext>
             </a:extLst>
           </p:cNvPr>
@@ -15411,7 +15411,7 @@
           <p:cNvPr id="4" name="footer-book">
             <a:extLst xmlns:a="http://schemas.openxmlformats.org/drawingml/2006/main">
               <a:ext uri="{FF2B5EF4-FFF2-40B4-BE49-F238E27FC236}">
-                <a16:creationId xmlns:a16="http://schemas.microsoft.com/office/drawing/2014/main" id="{BBC99185-C73C-4753-A351-AA5E2452B86A}"/>
+                <a16:creationId xmlns:a16="http://schemas.microsoft.com/office/drawing/2014/main" id="{D7B969D1-68B9-4417-B63D-E71E3F15410E}"/>
               </a:ext>
             </a:extLst>
           </p:cNvPr>
@@ -15473,7 +15473,7 @@
           <p:cNvPr id="5" name="footer-number">
             <a:extLst xmlns:a="http://schemas.openxmlformats.org/drawingml/2006/main">
               <a:ext uri="{FF2B5EF4-FFF2-40B4-BE49-F238E27FC236}">
-                <a16:creationId xmlns:a16="http://schemas.microsoft.com/office/drawing/2014/main" id="{21DAB03C-B4D5-42C8-AE47-C523E5D7EF0D}"/>
+                <a16:creationId xmlns:a16="http://schemas.microsoft.com/office/drawing/2014/main" id="{3156DD4A-2301-4B03-B132-F8B4154A1E89}"/>
               </a:ext>
             </a:extLst>
           </p:cNvPr>
@@ -15539,7 +15539,7 @@
           <p:nvPr/>
         </p:nvPicPr>
         <p:blipFill>
-          <a:blip xmlns:r="http://schemas.openxmlformats.org/officeDocument/2006/relationships" xmlns:a="http://schemas.openxmlformats.org/drawingml/2006/main" r:embed="R907a3ebaedc64d31"/>
+          <a:blip xmlns:r="http://schemas.openxmlformats.org/officeDocument/2006/relationships" xmlns:a="http://schemas.openxmlformats.org/drawingml/2006/main" r:embed="Rdaed2d2c73b24879"/>
           <a:stretch xmlns:a="http://schemas.openxmlformats.org/drawingml/2006/main"/>
         </p:blipFill>
         <p:spPr>
@@ -15557,7 +15557,7 @@
           <p:cNvPr id="7" name="">
             <a:extLst xmlns:a="http://schemas.openxmlformats.org/drawingml/2006/main">
               <a:ext uri="{FF2B5EF4-FFF2-40B4-BE49-F238E27FC236}">
-                <a16:creationId xmlns:a16="http://schemas.microsoft.com/office/drawing/2014/main" id="{FE9C561F-ABFB-448B-B211-87A2815C3EB6}"/>
+                <a16:creationId xmlns:a16="http://schemas.microsoft.com/office/drawing/2014/main" id="{79AFA4E1-91A7-43D4-BE11-109E31D0FAA4}"/>
               </a:ext>
             </a:extLst>
           </p:cNvPr>
@@ -15617,7 +15617,7 @@
     </p:spTree>
     <p:extLst>
       <p:ext uri="{BB962C8B-B14F-4D97-AF65-F5344CB8AC3E}">
-        <p14:creationId xmlns:p14="http://schemas.microsoft.com/office/powerpoint/2010/main" val="555681731"/>
+        <p14:creationId xmlns:p14="http://schemas.microsoft.com/office/powerpoint/2010/main" val="858943690"/>
       </p:ext>
     </p:extLst>
   </p:cSld>
@@ -15648,7 +15648,7 @@
           <p:cNvPr id="8" name="chapter-label">
             <a:extLst xmlns:a="http://schemas.openxmlformats.org/drawingml/2006/main">
               <a:ext uri="{FF2B5EF4-FFF2-40B4-BE49-F238E27FC236}">
-                <a16:creationId xmlns:a16="http://schemas.microsoft.com/office/drawing/2014/main" id="{08C20F85-B660-45D6-A4AB-D9BF864DE834}"/>
+                <a16:creationId xmlns:a16="http://schemas.microsoft.com/office/drawing/2014/main" id="{6918AAAF-D62C-4916-B121-7E27E1E64FF7}"/>
               </a:ext>
             </a:extLst>
           </p:cNvPr>
@@ -15710,7 +15710,7 @@
           <p:cNvPr id="2" name="slide-title">
             <a:extLst xmlns:a="http://schemas.openxmlformats.org/drawingml/2006/main">
               <a:ext uri="{FF2B5EF4-FFF2-40B4-BE49-F238E27FC236}">
-                <a16:creationId xmlns:a16="http://schemas.microsoft.com/office/drawing/2014/main" id="{D69A2034-DD57-4819-8620-42AC065B2387}"/>
+                <a16:creationId xmlns:a16="http://schemas.microsoft.com/office/drawing/2014/main" id="{1AD90457-DF77-4DD9-9DEE-15376B01D57E}"/>
               </a:ext>
             </a:extLst>
           </p:cNvPr>
@@ -15772,7 +15772,7 @@
           <p:cNvPr id="3" name="footer-rule">
             <a:extLst xmlns:a="http://schemas.openxmlformats.org/drawingml/2006/main">
               <a:ext uri="{FF2B5EF4-FFF2-40B4-BE49-F238E27FC236}">
-                <a16:creationId xmlns:a16="http://schemas.microsoft.com/office/drawing/2014/main" id="{9E72AF3C-75B5-4160-B7EF-0C12B8DC5DA1}"/>
+                <a16:creationId xmlns:a16="http://schemas.microsoft.com/office/drawing/2014/main" id="{6913291F-5F90-45E3-A962-CEE1B63786B2}"/>
               </a:ext>
             </a:extLst>
           </p:cNvPr>
@@ -15803,7 +15803,7 @@
           <p:cNvPr id="4" name="footer-book">
             <a:extLst xmlns:a="http://schemas.openxmlformats.org/drawingml/2006/main">
               <a:ext uri="{FF2B5EF4-FFF2-40B4-BE49-F238E27FC236}">
-                <a16:creationId xmlns:a16="http://schemas.microsoft.com/office/drawing/2014/main" id="{DE48CBD0-C631-43CC-B480-269CEDA27B56}"/>
+                <a16:creationId xmlns:a16="http://schemas.microsoft.com/office/drawing/2014/main" id="{26702E40-EBFB-4C88-B40B-97B361619495}"/>
               </a:ext>
             </a:extLst>
           </p:cNvPr>
@@ -15865,7 +15865,7 @@
           <p:cNvPr id="5" name="footer-number">
             <a:extLst xmlns:a="http://schemas.openxmlformats.org/drawingml/2006/main">
               <a:ext uri="{FF2B5EF4-FFF2-40B4-BE49-F238E27FC236}">
-                <a16:creationId xmlns:a16="http://schemas.microsoft.com/office/drawing/2014/main" id="{82BABD51-5A0B-47D8-A4E5-0FD20D05D820}"/>
+                <a16:creationId xmlns:a16="http://schemas.microsoft.com/office/drawing/2014/main" id="{2982DEFB-129C-46B2-B798-6DE72CB0E3ED}"/>
               </a:ext>
             </a:extLst>
           </p:cNvPr>
@@ -15931,7 +15931,7 @@
           <p:nvPr/>
         </p:nvPicPr>
         <p:blipFill>
-          <a:blip xmlns:r="http://schemas.openxmlformats.org/officeDocument/2006/relationships" xmlns:a="http://schemas.openxmlformats.org/drawingml/2006/main" r:embed="R491ca0c6c4c24420"/>
+          <a:blip xmlns:r="http://schemas.openxmlformats.org/officeDocument/2006/relationships" xmlns:a="http://schemas.openxmlformats.org/drawingml/2006/main" r:embed="R6879569d9a184ea8"/>
           <a:stretch xmlns:a="http://schemas.openxmlformats.org/drawingml/2006/main"/>
         </p:blipFill>
         <p:spPr>
@@ -15949,7 +15949,7 @@
           <p:cNvPr id="7" name="">
             <a:extLst xmlns:a="http://schemas.openxmlformats.org/drawingml/2006/main">
               <a:ext uri="{FF2B5EF4-FFF2-40B4-BE49-F238E27FC236}">
-                <a16:creationId xmlns:a16="http://schemas.microsoft.com/office/drawing/2014/main" id="{6D25B729-27FE-4059-A12D-730F357B08AE}"/>
+                <a16:creationId xmlns:a16="http://schemas.microsoft.com/office/drawing/2014/main" id="{667B3B00-4230-465D-B86F-892C082EB035}"/>
               </a:ext>
             </a:extLst>
           </p:cNvPr>
@@ -16009,7 +16009,7 @@
     </p:spTree>
     <p:extLst>
       <p:ext uri="{BB962C8B-B14F-4D97-AF65-F5344CB8AC3E}">
-        <p14:creationId xmlns:p14="http://schemas.microsoft.com/office/powerpoint/2010/main" val="1611320417"/>
+        <p14:creationId xmlns:p14="http://schemas.microsoft.com/office/powerpoint/2010/main" val="1090872596"/>
       </p:ext>
     </p:extLst>
   </p:cSld>

</xml_diff>